<commit_message>
presentation in a good place
</commit_message>
<xml_diff>
--- a/presentation.pptx
+++ b/presentation.pptx
@@ -5,7 +5,7 @@
     <p:sldMasterId id="2147483648" r:id="rId1"/>
   </p:sldMasterIdLst>
   <p:notesMasterIdLst>
-    <p:notesMasterId r:id="rId21"/>
+    <p:notesMasterId r:id="rId24"/>
   </p:notesMasterIdLst>
   <p:sldIdLst>
     <p:sldId id="256" r:id="rId2"/>
@@ -17,16 +17,19 @@
     <p:sldId id="259" r:id="rId8"/>
     <p:sldId id="266" r:id="rId9"/>
     <p:sldId id="260" r:id="rId10"/>
-    <p:sldId id="281" r:id="rId11"/>
+    <p:sldId id="283" r:id="rId11"/>
     <p:sldId id="268" r:id="rId12"/>
     <p:sldId id="263" r:id="rId13"/>
-    <p:sldId id="264" r:id="rId14"/>
-    <p:sldId id="282" r:id="rId15"/>
-    <p:sldId id="265" r:id="rId16"/>
-    <p:sldId id="276" r:id="rId17"/>
-    <p:sldId id="278" r:id="rId18"/>
-    <p:sldId id="277" r:id="rId19"/>
-    <p:sldId id="270" r:id="rId20"/>
+    <p:sldId id="286" r:id="rId14"/>
+    <p:sldId id="264" r:id="rId15"/>
+    <p:sldId id="282" r:id="rId16"/>
+    <p:sldId id="284" r:id="rId17"/>
+    <p:sldId id="265" r:id="rId18"/>
+    <p:sldId id="276" r:id="rId19"/>
+    <p:sldId id="278" r:id="rId20"/>
+    <p:sldId id="277" r:id="rId21"/>
+    <p:sldId id="270" r:id="rId22"/>
+    <p:sldId id="285" r:id="rId23"/>
   </p:sldIdLst>
   <p:sldSz cx="9144000" cy="5143500" type="screen16x9"/>
   <p:notesSz cx="5143500" cy="9144000"/>
@@ -299,7 +302,10 @@
           <a:bodyPr/>
           <a:lstStyle/>
           <a:p>
-            <a:endParaRPr lang="en-US" dirty="0"/>
+            <a:r>
+              <a:rPr lang="en-US" dirty="0"/>
+              <a:t>Adam</a:t>
+            </a:r>
           </a:p>
         </p:txBody>
       </p:sp>
@@ -347,7 +353,7 @@
         <p:cNvPr id="1" name="">
           <a:extLst>
             <a:ext uri="{FF2B5EF4-FFF2-40B4-BE49-F238E27FC236}">
-              <a16:creationId xmlns:a16="http://schemas.microsoft.com/office/drawing/2014/main" id="{614DBD92-249C-809B-0ECF-EE409E7D041D}"/>
+              <a16:creationId xmlns:a16="http://schemas.microsoft.com/office/drawing/2014/main" id="{10FC2C6C-FF9C-AB62-9058-330FCA985428}"/>
             </a:ext>
           </a:extLst>
         </p:cNvPr>
@@ -367,7 +373,7 @@
           <p:cNvPr id="2" name="Slide Image Placeholder 1">
             <a:extLst>
               <a:ext uri="{FF2B5EF4-FFF2-40B4-BE49-F238E27FC236}">
-                <a16:creationId xmlns:a16="http://schemas.microsoft.com/office/drawing/2014/main" id="{1B5B5783-2C2F-8BCE-A494-90D5582F78BF}"/>
+                <a16:creationId xmlns:a16="http://schemas.microsoft.com/office/drawing/2014/main" id="{3253850A-3CC4-588E-C3F4-5365A7124083}"/>
               </a:ext>
             </a:extLst>
           </p:cNvPr>
@@ -385,7 +391,7 @@
           <p:cNvPr id="3" name="Notes Placeholder 2">
             <a:extLst>
               <a:ext uri="{FF2B5EF4-FFF2-40B4-BE49-F238E27FC236}">
-                <a16:creationId xmlns:a16="http://schemas.microsoft.com/office/drawing/2014/main" id="{5563CA56-3EC8-C529-DE02-4F4061AB4C01}"/>
+                <a16:creationId xmlns:a16="http://schemas.microsoft.com/office/drawing/2014/main" id="{C68E1E34-1B3A-4EEC-5409-2DE8CC22510B}"/>
               </a:ext>
             </a:extLst>
           </p:cNvPr>
@@ -401,7 +407,10 @@
           <a:bodyPr/>
           <a:lstStyle/>
           <a:p>
-            <a:endParaRPr lang="en-US" dirty="0"/>
+            <a:r>
+              <a:rPr lang="en-US" dirty="0"/>
+              <a:t>Ben</a:t>
+            </a:r>
           </a:p>
         </p:txBody>
       </p:sp>
@@ -410,7 +419,7 @@
           <p:cNvPr id="4" name="Slide Number Placeholder 3">
             <a:extLst>
               <a:ext uri="{FF2B5EF4-FFF2-40B4-BE49-F238E27FC236}">
-                <a16:creationId xmlns:a16="http://schemas.microsoft.com/office/drawing/2014/main" id="{82C2F26D-048D-1297-34FF-87D78DDDF2C3}"/>
+                <a16:creationId xmlns:a16="http://schemas.microsoft.com/office/drawing/2014/main" id="{5A5DE75A-92C1-C8E7-EFED-2B67E058FCE8}"/>
               </a:ext>
             </a:extLst>
           </p:cNvPr>
@@ -437,7 +446,7 @@
     </p:spTree>
     <p:extLst>
       <p:ext uri="{BB962C8B-B14F-4D97-AF65-F5344CB8AC3E}">
-        <p14:creationId xmlns:p14="http://schemas.microsoft.com/office/powerpoint/2010/main" val="2145476455"/>
+        <p14:creationId xmlns:p14="http://schemas.microsoft.com/office/powerpoint/2010/main" val="1991247706"/>
       </p:ext>
     </p:extLst>
   </p:cSld>
@@ -509,7 +518,10 @@
           <a:bodyPr/>
           <a:lstStyle/>
           <a:p>
-            <a:endParaRPr lang="en-US" dirty="0"/>
+            <a:r>
+              <a:rPr lang="en-US" dirty="0"/>
+              <a:t>Adam</a:t>
+            </a:r>
           </a:p>
         </p:txBody>
       </p:sp>
@@ -599,7 +611,10 @@
           <a:bodyPr/>
           <a:lstStyle/>
           <a:p>
-            <a:endParaRPr lang="en-US" dirty="0"/>
+            <a:r>
+              <a:rPr lang="en-US" dirty="0"/>
+              <a:t>Adam</a:t>
+            </a:r>
           </a:p>
         </p:txBody>
       </p:sp>
@@ -644,7 +659,13 @@
   <p:cSld>
     <p:spTree>
       <p:nvGrpSpPr>
-        <p:cNvPr id="1" name=""/>
+        <p:cNvPr id="1" name="">
+          <a:extLst>
+            <a:ext uri="{FF2B5EF4-FFF2-40B4-BE49-F238E27FC236}">
+              <a16:creationId xmlns:a16="http://schemas.microsoft.com/office/drawing/2014/main" id="{0BD92D23-F66A-A10B-6212-B21FCA327FDF}"/>
+            </a:ext>
+          </a:extLst>
+        </p:cNvPr>
         <p:cNvGrpSpPr/>
         <p:nvPr/>
       </p:nvGrpSpPr>
@@ -658,7 +679,13 @@
       </p:grpSpPr>
       <p:sp>
         <p:nvSpPr>
-          <p:cNvPr id="2" name="Slide Image Placeholder 1"/>
+          <p:cNvPr id="2" name="Slide Image Placeholder 1">
+            <a:extLst>
+              <a:ext uri="{FF2B5EF4-FFF2-40B4-BE49-F238E27FC236}">
+                <a16:creationId xmlns:a16="http://schemas.microsoft.com/office/drawing/2014/main" id="{C0DCC08E-D4D6-3279-7DC0-2FF7A9649AFD}"/>
+              </a:ext>
+            </a:extLst>
+          </p:cNvPr>
           <p:cNvSpPr>
             <a:spLocks noGrp="1" noRot="1" noChangeAspect="1"/>
           </p:cNvSpPr>
@@ -670,7 +697,13 @@
       </p:sp>
       <p:sp>
         <p:nvSpPr>
-          <p:cNvPr id="3" name="Notes Placeholder 2"/>
+          <p:cNvPr id="3" name="Notes Placeholder 2">
+            <a:extLst>
+              <a:ext uri="{FF2B5EF4-FFF2-40B4-BE49-F238E27FC236}">
+                <a16:creationId xmlns:a16="http://schemas.microsoft.com/office/drawing/2014/main" id="{3BE724FB-D7AC-8C11-4480-070BCE0F3D9B}"/>
+              </a:ext>
+            </a:extLst>
+          </p:cNvPr>
           <p:cNvSpPr>
             <a:spLocks noGrp="1"/>
           </p:cNvSpPr>
@@ -683,13 +716,22 @@
           <a:bodyPr/>
           <a:lstStyle/>
           <a:p>
-            <a:endParaRPr lang="en-US" dirty="0"/>
-          </a:p>
-        </p:txBody>
-      </p:sp>
-      <p:sp>
-        <p:nvSpPr>
-          <p:cNvPr id="4" name="Slide Number Placeholder 3"/>
+            <a:r>
+              <a:rPr lang="en-US" dirty="0"/>
+              <a:t>Adam</a:t>
+            </a:r>
+          </a:p>
+        </p:txBody>
+      </p:sp>
+      <p:sp>
+        <p:nvSpPr>
+          <p:cNvPr id="4" name="Slide Number Placeholder 3">
+            <a:extLst>
+              <a:ext uri="{FF2B5EF4-FFF2-40B4-BE49-F238E27FC236}">
+                <a16:creationId xmlns:a16="http://schemas.microsoft.com/office/drawing/2014/main" id="{4F51009D-C13C-7EEE-5442-CE78F9E45163}"/>
+              </a:ext>
+            </a:extLst>
+          </p:cNvPr>
           <p:cNvSpPr>
             <a:spLocks noGrp="1"/>
           </p:cNvSpPr>
@@ -713,7 +755,7 @@
     </p:spTree>
     <p:extLst>
       <p:ext uri="{BB962C8B-B14F-4D97-AF65-F5344CB8AC3E}">
-        <p14:creationId xmlns:p14="http://schemas.microsoft.com/office/powerpoint/2010/main" val="1024086991"/>
+        <p14:creationId xmlns:p14="http://schemas.microsoft.com/office/powerpoint/2010/main" val="1706925544"/>
       </p:ext>
     </p:extLst>
   </p:cSld>
@@ -851,7 +893,10 @@
           <a:bodyPr/>
           <a:lstStyle/>
           <a:p>
-            <a:endParaRPr lang="en-US" dirty="0"/>
+            <a:r>
+              <a:rPr lang="en-US" dirty="0"/>
+              <a:t>Adam</a:t>
+            </a:r>
           </a:p>
         </p:txBody>
       </p:sp>
@@ -892,6 +937,204 @@
 </file>
 
 <file path=ppt/notesSlides/notesSlide16.xml><?xml version="1.0" encoding="utf-8"?>
+<p:notes xmlns:a="http://schemas.openxmlformats.org/drawingml/2006/main" xmlns:r="http://schemas.openxmlformats.org/officeDocument/2006/relationships" xmlns:p="http://schemas.openxmlformats.org/presentationml/2006/main">
+  <p:cSld>
+    <p:spTree>
+      <p:nvGrpSpPr>
+        <p:cNvPr id="1" name="">
+          <a:extLst>
+            <a:ext uri="{FF2B5EF4-FFF2-40B4-BE49-F238E27FC236}">
+              <a16:creationId xmlns:a16="http://schemas.microsoft.com/office/drawing/2014/main" id="{A1A0251F-770F-7B09-803D-4E22A488BE58}"/>
+            </a:ext>
+          </a:extLst>
+        </p:cNvPr>
+        <p:cNvGrpSpPr/>
+        <p:nvPr/>
+      </p:nvGrpSpPr>
+      <p:grpSpPr>
+        <a:xfrm>
+          <a:off x="0" y="0"/>
+          <a:ext cx="0" cy="0"/>
+          <a:chOff x="0" y="0"/>
+          <a:chExt cx="0" cy="0"/>
+        </a:xfrm>
+      </p:grpSpPr>
+      <p:sp>
+        <p:nvSpPr>
+          <p:cNvPr id="2" name="Slide Image Placeholder 1">
+            <a:extLst>
+              <a:ext uri="{FF2B5EF4-FFF2-40B4-BE49-F238E27FC236}">
+                <a16:creationId xmlns:a16="http://schemas.microsoft.com/office/drawing/2014/main" id="{E7662BA0-880A-00CF-B278-46F860AE3D6B}"/>
+              </a:ext>
+            </a:extLst>
+          </p:cNvPr>
+          <p:cNvSpPr>
+            <a:spLocks noGrp="1" noRot="1" noChangeAspect="1"/>
+          </p:cNvSpPr>
+          <p:nvPr>
+            <p:ph type="sldImg"/>
+          </p:nvPr>
+        </p:nvSpPr>
+        <p:spPr/>
+      </p:sp>
+      <p:sp>
+        <p:nvSpPr>
+          <p:cNvPr id="3" name="Notes Placeholder 2">
+            <a:extLst>
+              <a:ext uri="{FF2B5EF4-FFF2-40B4-BE49-F238E27FC236}">
+                <a16:creationId xmlns:a16="http://schemas.microsoft.com/office/drawing/2014/main" id="{1ABDF587-D57F-D28E-7E7D-C66643D6E085}"/>
+              </a:ext>
+            </a:extLst>
+          </p:cNvPr>
+          <p:cNvSpPr>
+            <a:spLocks noGrp="1"/>
+          </p:cNvSpPr>
+          <p:nvPr>
+            <p:ph type="body" idx="1"/>
+          </p:nvPr>
+        </p:nvSpPr>
+        <p:spPr/>
+        <p:txBody>
+          <a:bodyPr/>
+          <a:lstStyle/>
+          <a:p>
+            <a:r>
+              <a:rPr lang="en-US" dirty="0"/>
+              <a:t>Adam</a:t>
+            </a:r>
+          </a:p>
+        </p:txBody>
+      </p:sp>
+      <p:sp>
+        <p:nvSpPr>
+          <p:cNvPr id="4" name="Slide Number Placeholder 3">
+            <a:extLst>
+              <a:ext uri="{FF2B5EF4-FFF2-40B4-BE49-F238E27FC236}">
+                <a16:creationId xmlns:a16="http://schemas.microsoft.com/office/drawing/2014/main" id="{F652353C-55BA-849C-0556-C77C7D157C94}"/>
+              </a:ext>
+            </a:extLst>
+          </p:cNvPr>
+          <p:cNvSpPr>
+            <a:spLocks noGrp="1"/>
+          </p:cNvSpPr>
+          <p:nvPr>
+            <p:ph type="sldNum" sz="quarter" idx="10"/>
+          </p:nvPr>
+        </p:nvSpPr>
+        <p:spPr/>
+        <p:txBody>
+          <a:bodyPr/>
+          <a:lstStyle/>
+          <a:p>
+            <a:fld id="{F7021451-1387-4CA6-816F-3879F97B5CBC}" type="slidenum">
+              <a:rPr lang="en-US"/>
+              <a:t>16</a:t>
+            </a:fld>
+            <a:endParaRPr lang="en-US"/>
+          </a:p>
+        </p:txBody>
+      </p:sp>
+    </p:spTree>
+    <p:extLst>
+      <p:ext uri="{BB962C8B-B14F-4D97-AF65-F5344CB8AC3E}">
+        <p14:creationId xmlns:p14="http://schemas.microsoft.com/office/powerpoint/2010/main" val="3982917720"/>
+      </p:ext>
+    </p:extLst>
+  </p:cSld>
+  <p:clrMapOvr>
+    <a:masterClrMapping/>
+  </p:clrMapOvr>
+</p:notes>
+</file>
+
+<file path=ppt/notesSlides/notesSlide17.xml><?xml version="1.0" encoding="utf-8"?>
+<p:notes xmlns:a="http://schemas.openxmlformats.org/drawingml/2006/main" xmlns:r="http://schemas.openxmlformats.org/officeDocument/2006/relationships" xmlns:p="http://schemas.openxmlformats.org/presentationml/2006/main">
+  <p:cSld>
+    <p:spTree>
+      <p:nvGrpSpPr>
+        <p:cNvPr id="1" name=""/>
+        <p:cNvGrpSpPr/>
+        <p:nvPr/>
+      </p:nvGrpSpPr>
+      <p:grpSpPr>
+        <a:xfrm>
+          <a:off x="0" y="0"/>
+          <a:ext cx="0" cy="0"/>
+          <a:chOff x="0" y="0"/>
+          <a:chExt cx="0" cy="0"/>
+        </a:xfrm>
+      </p:grpSpPr>
+      <p:sp>
+        <p:nvSpPr>
+          <p:cNvPr id="2" name="Slide Image Placeholder 1"/>
+          <p:cNvSpPr>
+            <a:spLocks noGrp="1" noRot="1" noChangeAspect="1"/>
+          </p:cNvSpPr>
+          <p:nvPr>
+            <p:ph type="sldImg"/>
+          </p:nvPr>
+        </p:nvSpPr>
+        <p:spPr/>
+      </p:sp>
+      <p:sp>
+        <p:nvSpPr>
+          <p:cNvPr id="3" name="Notes Placeholder 2"/>
+          <p:cNvSpPr>
+            <a:spLocks noGrp="1"/>
+          </p:cNvSpPr>
+          <p:nvPr>
+            <p:ph type="body" idx="1"/>
+          </p:nvPr>
+        </p:nvSpPr>
+        <p:spPr/>
+        <p:txBody>
+          <a:bodyPr/>
+          <a:lstStyle/>
+          <a:p>
+            <a:r>
+              <a:rPr lang="en-US" dirty="0"/>
+              <a:t>Ben</a:t>
+            </a:r>
+          </a:p>
+        </p:txBody>
+      </p:sp>
+      <p:sp>
+        <p:nvSpPr>
+          <p:cNvPr id="4" name="Slide Number Placeholder 3"/>
+          <p:cNvSpPr>
+            <a:spLocks noGrp="1"/>
+          </p:cNvSpPr>
+          <p:nvPr>
+            <p:ph type="sldNum" sz="quarter" idx="10"/>
+          </p:nvPr>
+        </p:nvSpPr>
+        <p:spPr/>
+        <p:txBody>
+          <a:bodyPr/>
+          <a:lstStyle/>
+          <a:p>
+            <a:fld id="{F7021451-1387-4CA6-816F-3879F97B5CBC}" type="slidenum">
+              <a:rPr lang="en-US"/>
+              <a:t>17</a:t>
+            </a:fld>
+            <a:endParaRPr lang="en-US"/>
+          </a:p>
+        </p:txBody>
+      </p:sp>
+    </p:spTree>
+    <p:extLst>
+      <p:ext uri="{BB962C8B-B14F-4D97-AF65-F5344CB8AC3E}">
+        <p14:creationId xmlns:p14="http://schemas.microsoft.com/office/powerpoint/2010/main" val="1024086991"/>
+      </p:ext>
+    </p:extLst>
+  </p:cSld>
+  <p:clrMapOvr>
+    <a:masterClrMapping/>
+  </p:clrMapOvr>
+</p:notes>
+</file>
+
+<file path=ppt/notesSlides/notesSlide18.xml><?xml version="1.0" encoding="utf-8"?>
 <p:notes xmlns:a="http://schemas.openxmlformats.org/drawingml/2006/main" xmlns:r="http://schemas.openxmlformats.org/officeDocument/2006/relationships" xmlns:p="http://schemas.openxmlformats.org/presentationml/2006/main">
   <p:cSld>
     <p:spTree>
@@ -953,7 +1196,10 @@
           <a:bodyPr/>
           <a:lstStyle/>
           <a:p>
-            <a:endParaRPr lang="en-US" dirty="0"/>
+            <a:r>
+              <a:rPr lang="en-US" dirty="0"/>
+              <a:t>Ben</a:t>
+            </a:r>
           </a:p>
         </p:txBody>
       </p:sp>
@@ -980,7 +1226,7 @@
           <a:p>
             <a:fld id="{F7021451-1387-4CA6-816F-3879F97B5CBC}" type="slidenum">
               <a:rPr lang="en-US"/>
-              <a:t>16</a:t>
+              <a:t>18</a:t>
             </a:fld>
             <a:endParaRPr lang="en-US"/>
           </a:p>
@@ -999,7 +1245,7 @@
 </p:notes>
 </file>
 
-<file path=ppt/notesSlides/notesSlide17.xml><?xml version="1.0" encoding="utf-8"?>
+<file path=ppt/notesSlides/notesSlide19.xml><?xml version="1.0" encoding="utf-8"?>
 <p:notes xmlns:a="http://schemas.openxmlformats.org/drawingml/2006/main" xmlns:r="http://schemas.openxmlformats.org/officeDocument/2006/relationships" xmlns:p="http://schemas.openxmlformats.org/presentationml/2006/main">
   <p:cSld>
     <p:spTree>
@@ -1061,7 +1307,10 @@
           <a:bodyPr/>
           <a:lstStyle/>
           <a:p>
-            <a:endParaRPr lang="en-US" dirty="0"/>
+            <a:r>
+              <a:rPr lang="en-US" dirty="0"/>
+              <a:t>Ben</a:t>
+            </a:r>
           </a:p>
         </p:txBody>
       </p:sp>
@@ -1088,7 +1337,7 @@
           <a:p>
             <a:fld id="{F7021451-1387-4CA6-816F-3879F97B5CBC}" type="slidenum">
               <a:rPr lang="en-US"/>
-              <a:t>17</a:t>
+              <a:t>19</a:t>
             </a:fld>
             <a:endParaRPr lang="en-US"/>
           </a:p>
@@ -1098,114 +1347,6 @@
     <p:extLst>
       <p:ext uri="{BB962C8B-B14F-4D97-AF65-F5344CB8AC3E}">
         <p14:creationId xmlns:p14="http://schemas.microsoft.com/office/powerpoint/2010/main" val="2077682158"/>
-      </p:ext>
-    </p:extLst>
-  </p:cSld>
-  <p:clrMapOvr>
-    <a:masterClrMapping/>
-  </p:clrMapOvr>
-</p:notes>
-</file>
-
-<file path=ppt/notesSlides/notesSlide18.xml><?xml version="1.0" encoding="utf-8"?>
-<p:notes xmlns:a="http://schemas.openxmlformats.org/drawingml/2006/main" xmlns:r="http://schemas.openxmlformats.org/officeDocument/2006/relationships" xmlns:p="http://schemas.openxmlformats.org/presentationml/2006/main">
-  <p:cSld>
-    <p:spTree>
-      <p:nvGrpSpPr>
-        <p:cNvPr id="1" name="">
-          <a:extLst>
-            <a:ext uri="{FF2B5EF4-FFF2-40B4-BE49-F238E27FC236}">
-              <a16:creationId xmlns:a16="http://schemas.microsoft.com/office/drawing/2014/main" id="{433956E8-FF6C-195A-C002-2D94E53AEF4A}"/>
-            </a:ext>
-          </a:extLst>
-        </p:cNvPr>
-        <p:cNvGrpSpPr/>
-        <p:nvPr/>
-      </p:nvGrpSpPr>
-      <p:grpSpPr>
-        <a:xfrm>
-          <a:off x="0" y="0"/>
-          <a:ext cx="0" cy="0"/>
-          <a:chOff x="0" y="0"/>
-          <a:chExt cx="0" cy="0"/>
-        </a:xfrm>
-      </p:grpSpPr>
-      <p:sp>
-        <p:nvSpPr>
-          <p:cNvPr id="2" name="Slide Image Placeholder 1">
-            <a:extLst>
-              <a:ext uri="{FF2B5EF4-FFF2-40B4-BE49-F238E27FC236}">
-                <a16:creationId xmlns:a16="http://schemas.microsoft.com/office/drawing/2014/main" id="{040F981A-CCD0-20A5-8418-A489019B4670}"/>
-              </a:ext>
-            </a:extLst>
-          </p:cNvPr>
-          <p:cNvSpPr>
-            <a:spLocks noGrp="1" noRot="1" noChangeAspect="1"/>
-          </p:cNvSpPr>
-          <p:nvPr>
-            <p:ph type="sldImg"/>
-          </p:nvPr>
-        </p:nvSpPr>
-        <p:spPr/>
-      </p:sp>
-      <p:sp>
-        <p:nvSpPr>
-          <p:cNvPr id="3" name="Notes Placeholder 2">
-            <a:extLst>
-              <a:ext uri="{FF2B5EF4-FFF2-40B4-BE49-F238E27FC236}">
-                <a16:creationId xmlns:a16="http://schemas.microsoft.com/office/drawing/2014/main" id="{D0B3EACC-4871-F588-8D52-150999526404}"/>
-              </a:ext>
-            </a:extLst>
-          </p:cNvPr>
-          <p:cNvSpPr>
-            <a:spLocks noGrp="1"/>
-          </p:cNvSpPr>
-          <p:nvPr>
-            <p:ph type="body" idx="1"/>
-          </p:nvPr>
-        </p:nvSpPr>
-        <p:spPr/>
-        <p:txBody>
-          <a:bodyPr/>
-          <a:lstStyle/>
-          <a:p>
-            <a:endParaRPr lang="en-US" dirty="0"/>
-          </a:p>
-        </p:txBody>
-      </p:sp>
-      <p:sp>
-        <p:nvSpPr>
-          <p:cNvPr id="4" name="Slide Number Placeholder 3">
-            <a:extLst>
-              <a:ext uri="{FF2B5EF4-FFF2-40B4-BE49-F238E27FC236}">
-                <a16:creationId xmlns:a16="http://schemas.microsoft.com/office/drawing/2014/main" id="{5DF48514-76A1-3F48-DD80-ADBFD70CCAC5}"/>
-              </a:ext>
-            </a:extLst>
-          </p:cNvPr>
-          <p:cNvSpPr>
-            <a:spLocks noGrp="1"/>
-          </p:cNvSpPr>
-          <p:nvPr>
-            <p:ph type="sldNum" sz="quarter" idx="10"/>
-          </p:nvPr>
-        </p:nvSpPr>
-        <p:spPr/>
-        <p:txBody>
-          <a:bodyPr/>
-          <a:lstStyle/>
-          <a:p>
-            <a:fld id="{F7021451-1387-4CA6-816F-3879F97B5CBC}" type="slidenum">
-              <a:rPr lang="en-US"/>
-              <a:t>18</a:t>
-            </a:fld>
-            <a:endParaRPr lang="en-US"/>
-          </a:p>
-        </p:txBody>
-      </p:sp>
-    </p:spTree>
-    <p:extLst>
-      <p:ext uri="{BB962C8B-B14F-4D97-AF65-F5344CB8AC3E}">
-        <p14:creationId xmlns:p14="http://schemas.microsoft.com/office/powerpoint/2010/main" val="1063543019"/>
       </p:ext>
     </p:extLst>
   </p:cSld>
@@ -1259,7 +1400,10 @@
           <a:bodyPr/>
           <a:lstStyle/>
           <a:p>
-            <a:endParaRPr lang="en-US" dirty="0"/>
+            <a:r>
+              <a:rPr lang="en-US" dirty="0"/>
+              <a:t>Adam</a:t>
+            </a:r>
           </a:p>
         </p:txBody>
       </p:sp>
@@ -1290,6 +1434,307 @@
     <p:extLst>
       <p:ext uri="{BB962C8B-B14F-4D97-AF65-F5344CB8AC3E}">
         <p14:creationId xmlns:p14="http://schemas.microsoft.com/office/powerpoint/2010/main" val="1024086991"/>
+      </p:ext>
+    </p:extLst>
+  </p:cSld>
+  <p:clrMapOvr>
+    <a:masterClrMapping/>
+  </p:clrMapOvr>
+</p:notes>
+</file>
+
+<file path=ppt/notesSlides/notesSlide20.xml><?xml version="1.0" encoding="utf-8"?>
+<p:notes xmlns:a="http://schemas.openxmlformats.org/drawingml/2006/main" xmlns:r="http://schemas.openxmlformats.org/officeDocument/2006/relationships" xmlns:p="http://schemas.openxmlformats.org/presentationml/2006/main">
+  <p:cSld>
+    <p:spTree>
+      <p:nvGrpSpPr>
+        <p:cNvPr id="1" name="">
+          <a:extLst>
+            <a:ext uri="{FF2B5EF4-FFF2-40B4-BE49-F238E27FC236}">
+              <a16:creationId xmlns:a16="http://schemas.microsoft.com/office/drawing/2014/main" id="{433956E8-FF6C-195A-C002-2D94E53AEF4A}"/>
+            </a:ext>
+          </a:extLst>
+        </p:cNvPr>
+        <p:cNvGrpSpPr/>
+        <p:nvPr/>
+      </p:nvGrpSpPr>
+      <p:grpSpPr>
+        <a:xfrm>
+          <a:off x="0" y="0"/>
+          <a:ext cx="0" cy="0"/>
+          <a:chOff x="0" y="0"/>
+          <a:chExt cx="0" cy="0"/>
+        </a:xfrm>
+      </p:grpSpPr>
+      <p:sp>
+        <p:nvSpPr>
+          <p:cNvPr id="2" name="Slide Image Placeholder 1">
+            <a:extLst>
+              <a:ext uri="{FF2B5EF4-FFF2-40B4-BE49-F238E27FC236}">
+                <a16:creationId xmlns:a16="http://schemas.microsoft.com/office/drawing/2014/main" id="{040F981A-CCD0-20A5-8418-A489019B4670}"/>
+              </a:ext>
+            </a:extLst>
+          </p:cNvPr>
+          <p:cNvSpPr>
+            <a:spLocks noGrp="1" noRot="1" noChangeAspect="1"/>
+          </p:cNvSpPr>
+          <p:nvPr>
+            <p:ph type="sldImg"/>
+          </p:nvPr>
+        </p:nvSpPr>
+        <p:spPr/>
+      </p:sp>
+      <p:sp>
+        <p:nvSpPr>
+          <p:cNvPr id="3" name="Notes Placeholder 2">
+            <a:extLst>
+              <a:ext uri="{FF2B5EF4-FFF2-40B4-BE49-F238E27FC236}">
+                <a16:creationId xmlns:a16="http://schemas.microsoft.com/office/drawing/2014/main" id="{D0B3EACC-4871-F588-8D52-150999526404}"/>
+              </a:ext>
+            </a:extLst>
+          </p:cNvPr>
+          <p:cNvSpPr>
+            <a:spLocks noGrp="1"/>
+          </p:cNvSpPr>
+          <p:nvPr>
+            <p:ph type="body" idx="1"/>
+          </p:nvPr>
+        </p:nvSpPr>
+        <p:spPr/>
+        <p:txBody>
+          <a:bodyPr/>
+          <a:lstStyle/>
+          <a:p>
+            <a:r>
+              <a:rPr lang="en-US" dirty="0"/>
+              <a:t>Ben</a:t>
+            </a:r>
+          </a:p>
+        </p:txBody>
+      </p:sp>
+      <p:sp>
+        <p:nvSpPr>
+          <p:cNvPr id="4" name="Slide Number Placeholder 3">
+            <a:extLst>
+              <a:ext uri="{FF2B5EF4-FFF2-40B4-BE49-F238E27FC236}">
+                <a16:creationId xmlns:a16="http://schemas.microsoft.com/office/drawing/2014/main" id="{5DF48514-76A1-3F48-DD80-ADBFD70CCAC5}"/>
+              </a:ext>
+            </a:extLst>
+          </p:cNvPr>
+          <p:cNvSpPr>
+            <a:spLocks noGrp="1"/>
+          </p:cNvSpPr>
+          <p:nvPr>
+            <p:ph type="sldNum" sz="quarter" idx="10"/>
+          </p:nvPr>
+        </p:nvSpPr>
+        <p:spPr/>
+        <p:txBody>
+          <a:bodyPr/>
+          <a:lstStyle/>
+          <a:p>
+            <a:fld id="{F7021451-1387-4CA6-816F-3879F97B5CBC}" type="slidenum">
+              <a:rPr lang="en-US"/>
+              <a:t>20</a:t>
+            </a:fld>
+            <a:endParaRPr lang="en-US"/>
+          </a:p>
+        </p:txBody>
+      </p:sp>
+    </p:spTree>
+    <p:extLst>
+      <p:ext uri="{BB962C8B-B14F-4D97-AF65-F5344CB8AC3E}">
+        <p14:creationId xmlns:p14="http://schemas.microsoft.com/office/powerpoint/2010/main" val="1063543019"/>
+      </p:ext>
+    </p:extLst>
+  </p:cSld>
+  <p:clrMapOvr>
+    <a:masterClrMapping/>
+  </p:clrMapOvr>
+</p:notes>
+</file>
+
+<file path=ppt/notesSlides/notesSlide21.xml><?xml version="1.0" encoding="utf-8"?>
+<p:notes xmlns:a="http://schemas.openxmlformats.org/drawingml/2006/main" xmlns:r="http://schemas.openxmlformats.org/officeDocument/2006/relationships" xmlns:p="http://schemas.openxmlformats.org/presentationml/2006/main">
+  <p:cSld>
+    <p:spTree>
+      <p:nvGrpSpPr>
+        <p:cNvPr id="1" name=""/>
+        <p:cNvGrpSpPr/>
+        <p:nvPr/>
+      </p:nvGrpSpPr>
+      <p:grpSpPr>
+        <a:xfrm>
+          <a:off x="0" y="0"/>
+          <a:ext cx="0" cy="0"/>
+          <a:chOff x="0" y="0"/>
+          <a:chExt cx="0" cy="0"/>
+        </a:xfrm>
+      </p:grpSpPr>
+      <p:sp>
+        <p:nvSpPr>
+          <p:cNvPr id="2" name="Slide Image Placeholder 1"/>
+          <p:cNvSpPr>
+            <a:spLocks noGrp="1" noRot="1" noChangeAspect="1"/>
+          </p:cNvSpPr>
+          <p:nvPr>
+            <p:ph type="sldImg"/>
+          </p:nvPr>
+        </p:nvSpPr>
+        <p:spPr>
+          <a:xfrm>
+            <a:off x="-171450" y="1143000"/>
+            <a:ext cx="5486400" cy="3086100"/>
+          </a:xfrm>
+          <a:prstGeom prst="rect">
+            <a:avLst/>
+          </a:prstGeom>
+          <a:noFill/>
+          <a:ln w="12700">
+            <a:solidFill>
+              <a:prstClr val="black"/>
+            </a:solidFill>
+          </a:ln>
+        </p:spPr>
+      </p:sp>
+      <p:sp>
+        <p:nvSpPr>
+          <p:cNvPr id="3" name="Notes Placeholder 2"/>
+          <p:cNvSpPr>
+            <a:spLocks noGrp="1"/>
+          </p:cNvSpPr>
+          <p:nvPr>
+            <p:ph type="body" idx="1"/>
+          </p:nvPr>
+        </p:nvSpPr>
+        <p:spPr>
+          <a:xfrm>
+            <a:off x="514350" y="4400550"/>
+            <a:ext cx="4114800" cy="3600450"/>
+          </a:xfrm>
+          <a:prstGeom prst="rect">
+            <a:avLst/>
+          </a:prstGeom>
+        </p:spPr>
+        <p:txBody>
+          <a:bodyPr/>
+          <a:lstStyle/>
+          <a:p>
+            <a:r>
+              <a:rPr lang="en-US" dirty="0"/>
+              <a:t>Adam</a:t>
+            </a:r>
+          </a:p>
+        </p:txBody>
+      </p:sp>
+    </p:spTree>
+    <p:extLst>
+      <p:ext uri="{BB962C8B-B14F-4D97-AF65-F5344CB8AC3E}">
+        <p14:creationId xmlns:p14="http://schemas.microsoft.com/office/powerpoint/2010/main" val="332396070"/>
+      </p:ext>
+    </p:extLst>
+  </p:cSld>
+  <p:clrMapOvr>
+    <a:masterClrMapping/>
+  </p:clrMapOvr>
+</p:notes>
+</file>
+
+<file path=ppt/notesSlides/notesSlide22.xml><?xml version="1.0" encoding="utf-8"?>
+<p:notes xmlns:a="http://schemas.openxmlformats.org/drawingml/2006/main" xmlns:r="http://schemas.openxmlformats.org/officeDocument/2006/relationships" xmlns:p="http://schemas.openxmlformats.org/presentationml/2006/main">
+  <p:cSld>
+    <p:spTree>
+      <p:nvGrpSpPr>
+        <p:cNvPr id="1" name="">
+          <a:extLst>
+            <a:ext uri="{FF2B5EF4-FFF2-40B4-BE49-F238E27FC236}">
+              <a16:creationId xmlns:a16="http://schemas.microsoft.com/office/drawing/2014/main" id="{E6D19798-AA54-24D2-F44F-91219CC068B7}"/>
+            </a:ext>
+          </a:extLst>
+        </p:cNvPr>
+        <p:cNvGrpSpPr/>
+        <p:nvPr/>
+      </p:nvGrpSpPr>
+      <p:grpSpPr>
+        <a:xfrm>
+          <a:off x="0" y="0"/>
+          <a:ext cx="0" cy="0"/>
+          <a:chOff x="0" y="0"/>
+          <a:chExt cx="0" cy="0"/>
+        </a:xfrm>
+      </p:grpSpPr>
+      <p:sp>
+        <p:nvSpPr>
+          <p:cNvPr id="2" name="Slide Image Placeholder 1">
+            <a:extLst>
+              <a:ext uri="{FF2B5EF4-FFF2-40B4-BE49-F238E27FC236}">
+                <a16:creationId xmlns:a16="http://schemas.microsoft.com/office/drawing/2014/main" id="{12AF1E26-066A-10F5-76ED-72B7CBBACCBB}"/>
+              </a:ext>
+            </a:extLst>
+          </p:cNvPr>
+          <p:cNvSpPr>
+            <a:spLocks noGrp="1" noRot="1" noChangeAspect="1"/>
+          </p:cNvSpPr>
+          <p:nvPr>
+            <p:ph type="sldImg"/>
+          </p:nvPr>
+        </p:nvSpPr>
+        <p:spPr>
+          <a:xfrm>
+            <a:off x="-171450" y="1143000"/>
+            <a:ext cx="5486400" cy="3086100"/>
+          </a:xfrm>
+          <a:prstGeom prst="rect">
+            <a:avLst/>
+          </a:prstGeom>
+          <a:noFill/>
+          <a:ln w="12700">
+            <a:solidFill>
+              <a:prstClr val="black"/>
+            </a:solidFill>
+          </a:ln>
+        </p:spPr>
+      </p:sp>
+      <p:sp>
+        <p:nvSpPr>
+          <p:cNvPr id="3" name="Notes Placeholder 2">
+            <a:extLst>
+              <a:ext uri="{FF2B5EF4-FFF2-40B4-BE49-F238E27FC236}">
+                <a16:creationId xmlns:a16="http://schemas.microsoft.com/office/drawing/2014/main" id="{1658F421-89B6-4942-CFBB-40862BDB0FE7}"/>
+              </a:ext>
+            </a:extLst>
+          </p:cNvPr>
+          <p:cNvSpPr>
+            <a:spLocks noGrp="1"/>
+          </p:cNvSpPr>
+          <p:nvPr>
+            <p:ph type="body" idx="1"/>
+          </p:nvPr>
+        </p:nvSpPr>
+        <p:spPr>
+          <a:xfrm>
+            <a:off x="514350" y="4400550"/>
+            <a:ext cx="4114800" cy="3600450"/>
+          </a:xfrm>
+          <a:prstGeom prst="rect">
+            <a:avLst/>
+          </a:prstGeom>
+        </p:spPr>
+        <p:txBody>
+          <a:bodyPr/>
+          <a:lstStyle/>
+          <a:p>
+            <a:r>
+              <a:rPr lang="en-US" dirty="0"/>
+              <a:t>Adam</a:t>
+            </a:r>
+          </a:p>
+        </p:txBody>
+      </p:sp>
+    </p:spTree>
+    <p:extLst>
+      <p:ext uri="{BB962C8B-B14F-4D97-AF65-F5344CB8AC3E}">
+        <p14:creationId xmlns:p14="http://schemas.microsoft.com/office/powerpoint/2010/main" val="4194200881"/>
       </p:ext>
     </p:extLst>
   </p:cSld>
@@ -1343,7 +1788,10 @@
           <a:bodyPr/>
           <a:lstStyle/>
           <a:p>
-            <a:endParaRPr lang="en-US" dirty="0"/>
+            <a:r>
+              <a:rPr lang="en-US" dirty="0"/>
+              <a:t>Ben</a:t>
+            </a:r>
           </a:p>
         </p:txBody>
       </p:sp>
@@ -1445,7 +1893,10 @@
           <a:bodyPr/>
           <a:lstStyle/>
           <a:p>
-            <a:endParaRPr lang="en-US" dirty="0"/>
+            <a:r>
+              <a:rPr lang="en-US" dirty="0"/>
+              <a:t>Ben</a:t>
+            </a:r>
           </a:p>
         </p:txBody>
       </p:sp>
@@ -1553,7 +2004,10 @@
           <a:bodyPr/>
           <a:lstStyle/>
           <a:p>
-            <a:endParaRPr lang="en-US" dirty="0"/>
+            <a:r>
+              <a:rPr lang="en-US" dirty="0"/>
+              <a:t>Ben</a:t>
+            </a:r>
           </a:p>
         </p:txBody>
       </p:sp>
@@ -1643,7 +2097,10 @@
           <a:bodyPr/>
           <a:lstStyle/>
           <a:p>
-            <a:endParaRPr lang="en-US" dirty="0"/>
+            <a:r>
+              <a:rPr lang="en-US" dirty="0"/>
+              <a:t>Adam</a:t>
+            </a:r>
           </a:p>
         </p:txBody>
       </p:sp>
@@ -1727,7 +2184,10 @@
           <a:bodyPr/>
           <a:lstStyle/>
           <a:p>
-            <a:endParaRPr lang="en-US" dirty="0"/>
+            <a:r>
+              <a:rPr lang="en-US" dirty="0"/>
+              <a:t>Adam</a:t>
+            </a:r>
           </a:p>
         </p:txBody>
       </p:sp>
@@ -1829,7 +2289,10 @@
           <a:bodyPr/>
           <a:lstStyle/>
           <a:p>
-            <a:endParaRPr lang="en-US" dirty="0"/>
+            <a:r>
+              <a:rPr lang="en-US" dirty="0"/>
+              <a:t>Ben</a:t>
+            </a:r>
           </a:p>
         </p:txBody>
       </p:sp>
@@ -1919,7 +2382,10 @@
           <a:bodyPr/>
           <a:lstStyle/>
           <a:p>
-            <a:endParaRPr lang="en-US" dirty="0"/>
+            <a:r>
+              <a:rPr lang="en-US" dirty="0"/>
+              <a:t>Ben</a:t>
+            </a:r>
           </a:p>
         </p:txBody>
       </p:sp>
@@ -2467,12 +2933,20 @@
 <file path=ppt/slides/slide10.xml><?xml version="1.0" encoding="utf-8"?>
 <p:sld xmlns:a="http://schemas.openxmlformats.org/drawingml/2006/main" xmlns:r="http://schemas.openxmlformats.org/officeDocument/2006/relationships" xmlns:p="http://schemas.openxmlformats.org/presentationml/2006/main">
   <p:cSld>
+    <p:bg>
+      <p:bgPr>
+        <a:solidFill>
+          <a:srgbClr val="F4F6FA"/>
+        </a:solidFill>
+        <a:effectLst/>
+      </p:bgPr>
+    </p:bg>
     <p:spTree>
       <p:nvGrpSpPr>
         <p:cNvPr id="1" name="">
           <a:extLst>
             <a:ext uri="{FF2B5EF4-FFF2-40B4-BE49-F238E27FC236}">
-              <a16:creationId xmlns:a16="http://schemas.microsoft.com/office/drawing/2014/main" id="{E8E106FC-3D5E-4435-06BA-5D9B77559C9B}"/>
+              <a16:creationId xmlns:a16="http://schemas.microsoft.com/office/drawing/2014/main" id="{C7367D58-AEEB-379F-A383-C0B9EB17B472}"/>
             </a:ext>
           </a:extLst>
         </p:cNvPr>
@@ -2492,7 +2966,7 @@
           <p:cNvPr id="2" name="Text 0">
             <a:extLst>
               <a:ext uri="{FF2B5EF4-FFF2-40B4-BE49-F238E27FC236}">
-                <a16:creationId xmlns:a16="http://schemas.microsoft.com/office/drawing/2014/main" id="{97B6FD26-9110-5A0E-5085-F2380FF08A54}"/>
+                <a16:creationId xmlns:a16="http://schemas.microsoft.com/office/drawing/2014/main" id="{FD548F24-5C74-8673-69C5-A455F8FE31CD}"/>
               </a:ext>
             </a:extLst>
           </p:cNvPr>
@@ -2537,7 +3011,7 @@
           <p:cNvPr id="3" name="Text 1">
             <a:extLst>
               <a:ext uri="{FF2B5EF4-FFF2-40B4-BE49-F238E27FC236}">
-                <a16:creationId xmlns:a16="http://schemas.microsoft.com/office/drawing/2014/main" id="{5204844B-07C4-18E7-E9ED-F5B2C1CBEA81}"/>
+                <a16:creationId xmlns:a16="http://schemas.microsoft.com/office/drawing/2014/main" id="{E2F021D6-9885-B3A0-0776-1A75ED3F994E}"/>
               </a:ext>
             </a:extLst>
           </p:cNvPr>
@@ -2582,7 +3056,7 @@
           <p:cNvPr id="5" name="Picture 4" descr="A graph of different colored lines&#10;&#10;AI-generated content may be incorrect.">
             <a:extLst>
               <a:ext uri="{FF2B5EF4-FFF2-40B4-BE49-F238E27FC236}">
-                <a16:creationId xmlns:a16="http://schemas.microsoft.com/office/drawing/2014/main" id="{2CDFC2AD-0F49-5025-ABF7-8C3EE10C19A7}"/>
+                <a16:creationId xmlns:a16="http://schemas.microsoft.com/office/drawing/2014/main" id="{624AC44F-1C91-3462-FB67-2757E9424872}"/>
               </a:ext>
             </a:extLst>
           </p:cNvPr>
@@ -2610,7 +3084,7 @@
     </p:spTree>
     <p:extLst>
       <p:ext uri="{BB962C8B-B14F-4D97-AF65-F5344CB8AC3E}">
-        <p14:creationId xmlns:p14="http://schemas.microsoft.com/office/powerpoint/2010/main" val="2644950187"/>
+        <p14:creationId xmlns:p14="http://schemas.microsoft.com/office/powerpoint/2010/main" val="441096018"/>
       </p:ext>
     </p:extLst>
   </p:cSld>
@@ -2748,7 +3222,7 @@
           <p:nvPr>
             <p:extLst>
               <p:ext uri="{D42A27DB-BD31-4B8C-83A1-F6EECF244321}">
-                <p14:modId xmlns:p14="http://schemas.microsoft.com/office/powerpoint/2010/main" val="1571106600"/>
+                <p14:modId xmlns:p14="http://schemas.microsoft.com/office/powerpoint/2010/main" val="266636203"/>
               </p:ext>
             </p:extLst>
           </p:nvPr>
@@ -3577,11 +4051,14 @@
                       <a:pPr marL="0" indent="0">
                         <a:buNone/>
                       </a:pPr>
-                      <a:endParaRPr lang="en-US" sz="1000" dirty="0">
-                        <a:latin typeface="Calibri" charset="0"/>
-                        <a:ea typeface="Calibri" charset="0"/>
-                        <a:cs typeface="Calibri" charset="0"/>
-                      </a:endParaRPr>
+                      <a:r>
+                        <a:rPr lang="en-US" sz="1000" b="1" dirty="0">
+                          <a:latin typeface="Calibri" charset="0"/>
+                          <a:ea typeface="Calibri" charset="0"/>
+                          <a:cs typeface="Calibri" charset="0"/>
+                        </a:rPr>
+                        <a:t>Controls:</a:t>
+                      </a:r>
                     </a:p>
                   </a:txBody>
                   <a:tcPr marL="101600" marR="101600" marT="50800" marB="50800">
@@ -5349,7 +5826,7 @@
         </p:nvSpPr>
         <p:spPr>
           <a:xfrm>
-            <a:off x="548640" y="4723447"/>
+            <a:off x="548640" y="4869180"/>
             <a:ext cx="3937635" cy="274320"/>
           </a:xfrm>
           <a:prstGeom prst="rect">
@@ -5768,6 +6245,349 @@
 
 <file path=ppt/slides/slide13.xml><?xml version="1.0" encoding="utf-8"?>
 <p:sld xmlns:a="http://schemas.openxmlformats.org/drawingml/2006/main" xmlns:r="http://schemas.openxmlformats.org/officeDocument/2006/relationships" xmlns:p="http://schemas.openxmlformats.org/presentationml/2006/main">
+  <p:cSld>
+    <p:bg>
+      <p:bgPr>
+        <a:solidFill>
+          <a:srgbClr val="F4F6FA"/>
+        </a:solidFill>
+        <a:effectLst/>
+      </p:bgPr>
+    </p:bg>
+    <p:spTree>
+      <p:nvGrpSpPr>
+        <p:cNvPr id="1" name="">
+          <a:extLst>
+            <a:ext uri="{FF2B5EF4-FFF2-40B4-BE49-F238E27FC236}">
+              <a16:creationId xmlns:a16="http://schemas.microsoft.com/office/drawing/2014/main" id="{A74ADDF9-1E28-2D81-FA15-476133CAA5AA}"/>
+            </a:ext>
+          </a:extLst>
+        </p:cNvPr>
+        <p:cNvGrpSpPr/>
+        <p:nvPr/>
+      </p:nvGrpSpPr>
+      <p:grpSpPr>
+        <a:xfrm>
+          <a:off x="0" y="0"/>
+          <a:ext cx="0" cy="0"/>
+          <a:chOff x="0" y="0"/>
+          <a:chExt cx="0" cy="0"/>
+        </a:xfrm>
+      </p:grpSpPr>
+      <p:sp>
+        <p:nvSpPr>
+          <p:cNvPr id="2" name="Text 0">
+            <a:extLst>
+              <a:ext uri="{FF2B5EF4-FFF2-40B4-BE49-F238E27FC236}">
+                <a16:creationId xmlns:a16="http://schemas.microsoft.com/office/drawing/2014/main" id="{2ED42810-9F7E-A03F-1E43-5F62E9B848F8}"/>
+              </a:ext>
+            </a:extLst>
+          </p:cNvPr>
+          <p:cNvSpPr/>
+          <p:nvPr/>
+        </p:nvSpPr>
+        <p:spPr>
+          <a:xfrm>
+            <a:off x="548640" y="274320"/>
+            <a:ext cx="8046720" cy="548640"/>
+          </a:xfrm>
+          <a:prstGeom prst="rect">
+            <a:avLst/>
+          </a:prstGeom>
+          <a:noFill/>
+          <a:ln/>
+        </p:spPr>
+        <p:txBody>
+          <a:bodyPr wrap="square" lIns="0" tIns="0" rIns="0" bIns="0" rtlCol="0" anchor="ctr"/>
+          <a:lstStyle/>
+          <a:p>
+            <a:pPr marL="0" indent="0">
+              <a:buNone/>
+            </a:pPr>
+            <a:r>
+              <a:rPr lang="en-US" sz="2400" b="1" dirty="0">
+                <a:solidFill>
+                  <a:srgbClr val="1E2761"/>
+                </a:solidFill>
+                <a:latin typeface="Georgia" pitchFamily="34" charset="0"/>
+                <a:ea typeface="Georgia" pitchFamily="34" charset="-122"/>
+                <a:cs typeface="Georgia" pitchFamily="34" charset="-120"/>
+              </a:rPr>
+              <a:t>Robustness: Parallel Trends &amp; Within-Field Share</a:t>
+            </a:r>
+            <a:endParaRPr lang="en-US" sz="2400" dirty="0"/>
+          </a:p>
+        </p:txBody>
+      </p:sp>
+      <p:sp>
+        <p:nvSpPr>
+          <p:cNvPr id="5" name="Text 1">
+            <a:extLst>
+              <a:ext uri="{FF2B5EF4-FFF2-40B4-BE49-F238E27FC236}">
+                <a16:creationId xmlns:a16="http://schemas.microsoft.com/office/drawing/2014/main" id="{A91479B2-2FDA-D0D2-1FC5-2E06CA983D4D}"/>
+              </a:ext>
+            </a:extLst>
+          </p:cNvPr>
+          <p:cNvSpPr/>
+          <p:nvPr/>
+        </p:nvSpPr>
+        <p:spPr>
+          <a:xfrm>
+            <a:off x="182880" y="3931920"/>
+            <a:ext cx="4114800" cy="548640"/>
+          </a:xfrm>
+          <a:prstGeom prst="rect">
+            <a:avLst/>
+          </a:prstGeom>
+          <a:noFill/>
+          <a:ln/>
+        </p:spPr>
+        <p:txBody>
+          <a:bodyPr wrap="square" rtlCol="0" anchor="ctr"/>
+          <a:lstStyle/>
+          <a:p>
+            <a:pPr marL="0" indent="0" algn="ctr">
+              <a:buNone/>
+            </a:pPr>
+            <a:r>
+              <a:rPr lang="en-US" sz="1100" dirty="0">
+                <a:solidFill>
+                  <a:srgbClr val="556688"/>
+                </a:solidFill>
+                <a:latin typeface="Calibri" pitchFamily="34" charset="0"/>
+                <a:ea typeface="Calibri" pitchFamily="34" charset="-122"/>
+                <a:cs typeface="Calibri" pitchFamily="34" charset="-120"/>
+              </a:rPr>
+              <a:t>Parallel trends pass (p = 0.56) in 18-month</a:t>
+            </a:r>
+            <a:endParaRPr lang="en-US" sz="1100" dirty="0"/>
+          </a:p>
+          <a:p>
+            <a:pPr marL="0" indent="0" algn="ctr">
+              <a:buNone/>
+            </a:pPr>
+            <a:r>
+              <a:rPr lang="en-US" sz="1100" dirty="0">
+                <a:solidFill>
+                  <a:srgbClr val="556688"/>
+                </a:solidFill>
+                <a:latin typeface="Calibri" pitchFamily="34" charset="0"/>
+                <a:ea typeface="Calibri" pitchFamily="34" charset="-122"/>
+                <a:cs typeface="Calibri" pitchFamily="34" charset="-120"/>
+              </a:rPr>
+              <a:t>pre-period with field FE</a:t>
+            </a:r>
+            <a:endParaRPr lang="en-US" sz="1100" dirty="0"/>
+          </a:p>
+        </p:txBody>
+      </p:sp>
+      <p:sp>
+        <p:nvSpPr>
+          <p:cNvPr id="6" name="Text 2">
+            <a:extLst>
+              <a:ext uri="{FF2B5EF4-FFF2-40B4-BE49-F238E27FC236}">
+                <a16:creationId xmlns:a16="http://schemas.microsoft.com/office/drawing/2014/main" id="{EE25CA79-DE28-752C-97BC-EDCC8C6F1196}"/>
+              </a:ext>
+            </a:extLst>
+          </p:cNvPr>
+          <p:cNvSpPr/>
+          <p:nvPr/>
+        </p:nvSpPr>
+        <p:spPr>
+          <a:xfrm>
+            <a:off x="4846320" y="3931920"/>
+            <a:ext cx="4114800" cy="548640"/>
+          </a:xfrm>
+          <a:prstGeom prst="rect">
+            <a:avLst/>
+          </a:prstGeom>
+          <a:noFill/>
+          <a:ln/>
+        </p:spPr>
+        <p:txBody>
+          <a:bodyPr wrap="square" rtlCol="0" anchor="ctr"/>
+          <a:lstStyle/>
+          <a:p>
+            <a:pPr marL="0" indent="0" algn="ctr">
+              <a:buNone/>
+            </a:pPr>
+            <a:r>
+              <a:rPr lang="en-US" sz="1100" dirty="0">
+                <a:solidFill>
+                  <a:srgbClr val="556688"/>
+                </a:solidFill>
+                <a:latin typeface="Calibri" pitchFamily="34" charset="0"/>
+                <a:ea typeface="Calibri" pitchFamily="34" charset="-122"/>
+                <a:cs typeface="Calibri" pitchFamily="34" charset="-120"/>
+              </a:rPr>
+              <a:t>Within-field citation share declines faster</a:t>
+            </a:r>
+            <a:endParaRPr lang="en-US" sz="1100" dirty="0"/>
+          </a:p>
+          <a:p>
+            <a:pPr marL="0" indent="0" algn="ctr">
+              <a:buNone/>
+            </a:pPr>
+            <a:r>
+              <a:rPr lang="en-US" sz="1100" dirty="0">
+                <a:solidFill>
+                  <a:srgbClr val="556688"/>
+                </a:solidFill>
+                <a:latin typeface="Calibri" pitchFamily="34" charset="0"/>
+                <a:ea typeface="Calibri" pitchFamily="34" charset="-122"/>
+                <a:cs typeface="Calibri" pitchFamily="34" charset="-120"/>
+              </a:rPr>
+              <a:t>in high-propensity fields post-4o</a:t>
+            </a:r>
+            <a:endParaRPr lang="en-US" sz="1100" dirty="0"/>
+          </a:p>
+        </p:txBody>
+      </p:sp>
+      <p:pic>
+        <p:nvPicPr>
+          <p:cNvPr id="8" name="Picture 7" descr="A graph with red and blue lines&#10;&#10;AI-generated content may be incorrect.">
+            <a:extLst>
+              <a:ext uri="{FF2B5EF4-FFF2-40B4-BE49-F238E27FC236}">
+                <a16:creationId xmlns:a16="http://schemas.microsoft.com/office/drawing/2014/main" id="{02FD7729-9CE4-BD14-CAF8-8B01260F4BE5}"/>
+              </a:ext>
+            </a:extLst>
+          </p:cNvPr>
+          <p:cNvPicPr>
+            <a:picLocks noChangeAspect="1"/>
+          </p:cNvPicPr>
+          <p:nvPr/>
+        </p:nvPicPr>
+        <p:blipFill>
+          <a:blip r:embed="rId3"/>
+          <a:stretch>
+            <a:fillRect/>
+          </a:stretch>
+        </p:blipFill>
+        <p:spPr>
+          <a:xfrm>
+            <a:off x="182880" y="1694066"/>
+            <a:ext cx="4255619" cy="2105411"/>
+          </a:xfrm>
+          <a:prstGeom prst="rect">
+            <a:avLst/>
+          </a:prstGeom>
+        </p:spPr>
+      </p:pic>
+      <p:pic>
+        <p:nvPicPr>
+          <p:cNvPr id="10" name="Picture 9" descr="A graph of a graph with red and blue lines&#10;&#10;AI-generated content may be incorrect.">
+            <a:extLst>
+              <a:ext uri="{FF2B5EF4-FFF2-40B4-BE49-F238E27FC236}">
+                <a16:creationId xmlns:a16="http://schemas.microsoft.com/office/drawing/2014/main" id="{5D683644-9BD6-8F7F-C310-C6ADCDCBF64D}"/>
+              </a:ext>
+            </a:extLst>
+          </p:cNvPr>
+          <p:cNvPicPr>
+            <a:picLocks noChangeAspect="1"/>
+          </p:cNvPicPr>
+          <p:nvPr/>
+        </p:nvPicPr>
+        <p:blipFill>
+          <a:blip r:embed="rId4"/>
+          <a:stretch>
+            <a:fillRect/>
+          </a:stretch>
+        </p:blipFill>
+        <p:spPr>
+          <a:xfrm>
+            <a:off x="4651190" y="1619094"/>
+            <a:ext cx="4255618" cy="2105411"/>
+          </a:xfrm>
+          <a:prstGeom prst="rect">
+            <a:avLst/>
+          </a:prstGeom>
+        </p:spPr>
+      </p:pic>
+      <p:sp>
+        <p:nvSpPr>
+          <p:cNvPr id="3" name="TextBox 2">
+            <a:extLst>
+              <a:ext uri="{FF2B5EF4-FFF2-40B4-BE49-F238E27FC236}">
+                <a16:creationId xmlns:a16="http://schemas.microsoft.com/office/drawing/2014/main" id="{2658E6F8-921A-B1CB-451C-66628B30CD48}"/>
+              </a:ext>
+            </a:extLst>
+          </p:cNvPr>
+          <p:cNvSpPr txBox="1"/>
+          <p:nvPr/>
+        </p:nvSpPr>
+        <p:spPr>
+          <a:xfrm>
+            <a:off x="304099" y="822960"/>
+            <a:ext cx="3932145" cy="738664"/>
+          </a:xfrm>
+          <a:prstGeom prst="rect">
+            <a:avLst/>
+          </a:prstGeom>
+          <a:noFill/>
+        </p:spPr>
+        <p:txBody>
+          <a:bodyPr wrap="square" rtlCol="0">
+            <a:spAutoFit/>
+          </a:bodyPr>
+          <a:lstStyle/>
+          <a:p>
+            <a:r>
+              <a:rPr lang="en-US" sz="1400" dirty="0"/>
+              <a:t>We expect parallel trends for the development of high AI propensity and low AI propensity fields before treatment</a:t>
+            </a:r>
+          </a:p>
+        </p:txBody>
+      </p:sp>
+      <p:sp>
+        <p:nvSpPr>
+          <p:cNvPr id="4" name="TextBox 3">
+            <a:extLst>
+              <a:ext uri="{FF2B5EF4-FFF2-40B4-BE49-F238E27FC236}">
+                <a16:creationId xmlns:a16="http://schemas.microsoft.com/office/drawing/2014/main" id="{22AF1E7D-D294-790D-B601-634AD8739D95}"/>
+              </a:ext>
+            </a:extLst>
+          </p:cNvPr>
+          <p:cNvSpPr txBox="1"/>
+          <p:nvPr/>
+        </p:nvSpPr>
+        <p:spPr>
+          <a:xfrm>
+            <a:off x="4564436" y="822960"/>
+            <a:ext cx="3932145" cy="523220"/>
+          </a:xfrm>
+          <a:prstGeom prst="rect">
+            <a:avLst/>
+          </a:prstGeom>
+          <a:noFill/>
+        </p:spPr>
+        <p:txBody>
+          <a:bodyPr wrap="square" rtlCol="0">
+            <a:spAutoFit/>
+          </a:bodyPr>
+          <a:lstStyle/>
+          <a:p>
+            <a:r>
+              <a:rPr lang="en-US" sz="1400" dirty="0"/>
+              <a:t>We expect within-field share of citations to drop more in high AI fields than in low AI fields</a:t>
+            </a:r>
+          </a:p>
+        </p:txBody>
+      </p:sp>
+    </p:spTree>
+    <p:extLst>
+      <p:ext uri="{BB962C8B-B14F-4D97-AF65-F5344CB8AC3E}">
+        <p14:creationId xmlns:p14="http://schemas.microsoft.com/office/powerpoint/2010/main" val="1330404079"/>
+      </p:ext>
+    </p:extLst>
+  </p:cSld>
+  <p:clrMapOvr>
+    <a:masterClrMapping/>
+  </p:clrMapOvr>
+</p:sld>
+</file>
+
+<file path=ppt/slides/slide14.xml><?xml version="1.0" encoding="utf-8"?>
+<p:sld xmlns:a="http://schemas.openxmlformats.org/drawingml/2006/main" xmlns:r="http://schemas.openxmlformats.org/officeDocument/2006/relationships" xmlns:p="http://schemas.openxmlformats.org/presentationml/2006/main" show="0">
   <p:cSld name="Slide 9">
     <p:bg>
       <p:bgPr>
@@ -5955,7 +6775,7 @@
 </p:sld>
 </file>
 
-<file path=ppt/slides/slide14.xml><?xml version="1.0" encoding="utf-8"?>
+<file path=ppt/slides/slide15.xml><?xml version="1.0" encoding="utf-8"?>
 <p:sld xmlns:a="http://schemas.openxmlformats.org/drawingml/2006/main" xmlns:r="http://schemas.openxmlformats.org/officeDocument/2006/relationships" xmlns:p="http://schemas.openxmlformats.org/presentationml/2006/main">
   <p:cSld>
     <p:spTree>
@@ -6451,7 +7271,592 @@
 </p:sld>
 </file>
 
-<file path=ppt/slides/slide15.xml><?xml version="1.0" encoding="utf-8"?>
+<file path=ppt/slides/slide16.xml><?xml version="1.0" encoding="utf-8"?>
+<p:sld xmlns:a="http://schemas.openxmlformats.org/drawingml/2006/main" xmlns:r="http://schemas.openxmlformats.org/officeDocument/2006/relationships" xmlns:p="http://schemas.openxmlformats.org/presentationml/2006/main">
+  <p:cSld>
+    <p:spTree>
+      <p:nvGrpSpPr>
+        <p:cNvPr id="1" name="">
+          <a:extLst>
+            <a:ext uri="{FF2B5EF4-FFF2-40B4-BE49-F238E27FC236}">
+              <a16:creationId xmlns:a16="http://schemas.microsoft.com/office/drawing/2014/main" id="{66AC4415-2D3D-97D2-DF84-EC3824D8DCC3}"/>
+            </a:ext>
+          </a:extLst>
+        </p:cNvPr>
+        <p:cNvGrpSpPr/>
+        <p:nvPr/>
+      </p:nvGrpSpPr>
+      <p:grpSpPr>
+        <a:xfrm>
+          <a:off x="0" y="0"/>
+          <a:ext cx="0" cy="0"/>
+          <a:chOff x="0" y="0"/>
+          <a:chExt cx="0" cy="0"/>
+        </a:xfrm>
+      </p:grpSpPr>
+      <p:sp>
+        <p:nvSpPr>
+          <p:cNvPr id="2" name="Text 0">
+            <a:extLst>
+              <a:ext uri="{FF2B5EF4-FFF2-40B4-BE49-F238E27FC236}">
+                <a16:creationId xmlns:a16="http://schemas.microsoft.com/office/drawing/2014/main" id="{A95367D9-8D6E-56C6-C8F9-6E2F75AD91CE}"/>
+              </a:ext>
+            </a:extLst>
+          </p:cNvPr>
+          <p:cNvSpPr/>
+          <p:nvPr/>
+        </p:nvSpPr>
+        <p:spPr>
+          <a:xfrm>
+            <a:off x="548640" y="274320"/>
+            <a:ext cx="8046720" cy="548640"/>
+          </a:xfrm>
+          <a:prstGeom prst="rect">
+            <a:avLst/>
+          </a:prstGeom>
+          <a:noFill/>
+          <a:ln/>
+        </p:spPr>
+        <p:txBody>
+          <a:bodyPr wrap="square" lIns="0" tIns="0" rIns="0" bIns="0" rtlCol="0" anchor="ctr"/>
+          <a:lstStyle/>
+          <a:p>
+            <a:pPr marL="0" indent="0">
+              <a:buNone/>
+            </a:pPr>
+            <a:r>
+              <a:rPr lang="en-US" sz="2800" b="1" dirty="0">
+                <a:solidFill>
+                  <a:srgbClr val="1E2761"/>
+                </a:solidFill>
+                <a:latin typeface="Georgia" pitchFamily="34" charset="0"/>
+                <a:ea typeface="Georgia" pitchFamily="34" charset="-122"/>
+                <a:cs typeface="Georgia" pitchFamily="34" charset="-120"/>
+              </a:rPr>
+              <a:t>Limitations</a:t>
+            </a:r>
+            <a:endParaRPr lang="en-US" sz="2800" dirty="0"/>
+          </a:p>
+        </p:txBody>
+      </p:sp>
+      <p:sp>
+        <p:nvSpPr>
+          <p:cNvPr id="3" name="Shape 1">
+            <a:extLst>
+              <a:ext uri="{FF2B5EF4-FFF2-40B4-BE49-F238E27FC236}">
+                <a16:creationId xmlns:a16="http://schemas.microsoft.com/office/drawing/2014/main" id="{063FDC7E-ABA4-EB76-0F45-111EA14E58C5}"/>
+              </a:ext>
+            </a:extLst>
+          </p:cNvPr>
+          <p:cNvSpPr/>
+          <p:nvPr/>
+        </p:nvSpPr>
+        <p:spPr>
+          <a:xfrm>
+            <a:off x="548640" y="1097280"/>
+            <a:ext cx="411480" cy="411480"/>
+          </a:xfrm>
+          <a:prstGeom prst="ellipse">
+            <a:avLst/>
+          </a:prstGeom>
+          <a:solidFill>
+            <a:srgbClr val="3A7BD5"/>
+          </a:solidFill>
+          <a:ln/>
+        </p:spPr>
+        <p:txBody>
+          <a:bodyPr/>
+          <a:lstStyle/>
+          <a:p>
+            <a:endParaRPr lang="en-US"/>
+          </a:p>
+        </p:txBody>
+      </p:sp>
+      <p:sp>
+        <p:nvSpPr>
+          <p:cNvPr id="4" name="Text 2">
+            <a:extLst>
+              <a:ext uri="{FF2B5EF4-FFF2-40B4-BE49-F238E27FC236}">
+                <a16:creationId xmlns:a16="http://schemas.microsoft.com/office/drawing/2014/main" id="{17C14BDE-444D-6646-B1AF-2FD042FD6079}"/>
+              </a:ext>
+            </a:extLst>
+          </p:cNvPr>
+          <p:cNvSpPr/>
+          <p:nvPr/>
+        </p:nvSpPr>
+        <p:spPr>
+          <a:xfrm>
+            <a:off x="548640" y="1097280"/>
+            <a:ext cx="411480" cy="411480"/>
+          </a:xfrm>
+          <a:prstGeom prst="rect">
+            <a:avLst/>
+          </a:prstGeom>
+          <a:noFill/>
+          <a:ln/>
+        </p:spPr>
+        <p:txBody>
+          <a:bodyPr wrap="square" rtlCol="0" anchor="ctr"/>
+          <a:lstStyle/>
+          <a:p>
+            <a:pPr marL="0" indent="0" algn="ctr">
+              <a:buNone/>
+            </a:pPr>
+            <a:r>
+              <a:rPr lang="en-US" sz="1600" b="1" dirty="0">
+                <a:solidFill>
+                  <a:srgbClr val="FFFFFF"/>
+                </a:solidFill>
+                <a:latin typeface="Calibri" pitchFamily="34" charset="0"/>
+                <a:ea typeface="Calibri" pitchFamily="34" charset="-122"/>
+                <a:cs typeface="Calibri" pitchFamily="34" charset="-120"/>
+              </a:rPr>
+              <a:t>1</a:t>
+            </a:r>
+            <a:endParaRPr lang="en-US" sz="1600" dirty="0"/>
+          </a:p>
+        </p:txBody>
+      </p:sp>
+      <p:sp>
+        <p:nvSpPr>
+          <p:cNvPr id="5" name="Text 3">
+            <a:extLst>
+              <a:ext uri="{FF2B5EF4-FFF2-40B4-BE49-F238E27FC236}">
+                <a16:creationId xmlns:a16="http://schemas.microsoft.com/office/drawing/2014/main" id="{580BE684-41F9-24A7-203D-5F86CA0A107A}"/>
+              </a:ext>
+            </a:extLst>
+          </p:cNvPr>
+          <p:cNvSpPr/>
+          <p:nvPr/>
+        </p:nvSpPr>
+        <p:spPr>
+          <a:xfrm>
+            <a:off x="1188720" y="1097280"/>
+            <a:ext cx="7406640" cy="320040"/>
+          </a:xfrm>
+          <a:prstGeom prst="rect">
+            <a:avLst/>
+          </a:prstGeom>
+          <a:noFill/>
+          <a:ln/>
+        </p:spPr>
+        <p:txBody>
+          <a:bodyPr wrap="square" lIns="0" tIns="0" rIns="0" bIns="0" rtlCol="0" anchor="ctr"/>
+          <a:lstStyle/>
+          <a:p>
+            <a:pPr marL="0" indent="0">
+              <a:buNone/>
+            </a:pPr>
+            <a:r>
+              <a:rPr lang="en-US" sz="1600" b="1" dirty="0">
+                <a:solidFill>
+                  <a:srgbClr val="1E2761"/>
+                </a:solidFill>
+                <a:latin typeface="Calibri" pitchFamily="34" charset="0"/>
+                <a:ea typeface="Calibri" pitchFamily="34" charset="-122"/>
+                <a:cs typeface="Calibri" pitchFamily="34" charset="-120"/>
+              </a:rPr>
+              <a:t>GPT-3.5 adoption may not predict GPT-4o adoption</a:t>
+            </a:r>
+            <a:endParaRPr lang="en-US" sz="1600" dirty="0"/>
+          </a:p>
+        </p:txBody>
+      </p:sp>
+      <p:sp>
+        <p:nvSpPr>
+          <p:cNvPr id="6" name="Text 4">
+            <a:extLst>
+              <a:ext uri="{FF2B5EF4-FFF2-40B4-BE49-F238E27FC236}">
+                <a16:creationId xmlns:a16="http://schemas.microsoft.com/office/drawing/2014/main" id="{C40859F1-E0C8-F128-1C87-A33CD2F82DFB}"/>
+              </a:ext>
+            </a:extLst>
+          </p:cNvPr>
+          <p:cNvSpPr/>
+          <p:nvPr/>
+        </p:nvSpPr>
+        <p:spPr>
+          <a:xfrm>
+            <a:off x="1188720" y="1444752"/>
+            <a:ext cx="7406640" cy="594360"/>
+          </a:xfrm>
+          <a:prstGeom prst="rect">
+            <a:avLst/>
+          </a:prstGeom>
+          <a:noFill/>
+          <a:ln/>
+        </p:spPr>
+        <p:txBody>
+          <a:bodyPr wrap="square" lIns="0" tIns="0" rIns="0" bIns="0" rtlCol="0" anchor="ctr"/>
+          <a:lstStyle/>
+          <a:p>
+            <a:pPr marL="0" indent="0">
+              <a:buNone/>
+            </a:pPr>
+            <a:r>
+              <a:rPr lang="en-US" sz="1200" dirty="0">
+                <a:solidFill>
+                  <a:srgbClr val="1E2761"/>
+                </a:solidFill>
+                <a:latin typeface="Calibri" pitchFamily="34" charset="0"/>
+                <a:ea typeface="Calibri" pitchFamily="34" charset="-122"/>
+                <a:cs typeface="Calibri" pitchFamily="34" charset="-120"/>
+              </a:rPr>
+              <a:t>Propensity scores capture structural field-level receptivity to LLM assistance, not adoption of a specific model. Measured during a pre-“gaming” period when there was no reputational cost to AI-influenced writing.</a:t>
+            </a:r>
+            <a:endParaRPr lang="en-US" sz="1200" dirty="0"/>
+          </a:p>
+        </p:txBody>
+      </p:sp>
+      <p:sp>
+        <p:nvSpPr>
+          <p:cNvPr id="7" name="Shape 5">
+            <a:extLst>
+              <a:ext uri="{FF2B5EF4-FFF2-40B4-BE49-F238E27FC236}">
+                <a16:creationId xmlns:a16="http://schemas.microsoft.com/office/drawing/2014/main" id="{8FA6C7BB-52F3-29FA-1E50-2F523B245605}"/>
+              </a:ext>
+            </a:extLst>
+          </p:cNvPr>
+          <p:cNvSpPr/>
+          <p:nvPr/>
+        </p:nvSpPr>
+        <p:spPr>
+          <a:xfrm>
+            <a:off x="548640" y="2286000"/>
+            <a:ext cx="411480" cy="411480"/>
+          </a:xfrm>
+          <a:prstGeom prst="ellipse">
+            <a:avLst/>
+          </a:prstGeom>
+          <a:solidFill>
+            <a:srgbClr val="3A7BD5"/>
+          </a:solidFill>
+          <a:ln/>
+        </p:spPr>
+        <p:txBody>
+          <a:bodyPr/>
+          <a:lstStyle/>
+          <a:p>
+            <a:endParaRPr lang="en-US"/>
+          </a:p>
+        </p:txBody>
+      </p:sp>
+      <p:sp>
+        <p:nvSpPr>
+          <p:cNvPr id="8" name="Text 6">
+            <a:extLst>
+              <a:ext uri="{FF2B5EF4-FFF2-40B4-BE49-F238E27FC236}">
+                <a16:creationId xmlns:a16="http://schemas.microsoft.com/office/drawing/2014/main" id="{50779AFE-AC26-3B17-DFFA-00FB8F4EF2C1}"/>
+              </a:ext>
+            </a:extLst>
+          </p:cNvPr>
+          <p:cNvSpPr/>
+          <p:nvPr/>
+        </p:nvSpPr>
+        <p:spPr>
+          <a:xfrm>
+            <a:off x="548640" y="2286000"/>
+            <a:ext cx="411480" cy="411480"/>
+          </a:xfrm>
+          <a:prstGeom prst="rect">
+            <a:avLst/>
+          </a:prstGeom>
+          <a:noFill/>
+          <a:ln/>
+        </p:spPr>
+        <p:txBody>
+          <a:bodyPr wrap="square" rtlCol="0" anchor="ctr"/>
+          <a:lstStyle/>
+          <a:p>
+            <a:pPr marL="0" indent="0" algn="ctr">
+              <a:buNone/>
+            </a:pPr>
+            <a:r>
+              <a:rPr lang="en-US" sz="1600" b="1" dirty="0">
+                <a:solidFill>
+                  <a:srgbClr val="FFFFFF"/>
+                </a:solidFill>
+                <a:latin typeface="Calibri" pitchFamily="34" charset="0"/>
+                <a:ea typeface="Calibri" pitchFamily="34" charset="-122"/>
+                <a:cs typeface="Calibri" pitchFamily="34" charset="-120"/>
+              </a:rPr>
+              <a:t>2</a:t>
+            </a:r>
+            <a:endParaRPr lang="en-US" sz="1600" dirty="0"/>
+          </a:p>
+        </p:txBody>
+      </p:sp>
+      <p:sp>
+        <p:nvSpPr>
+          <p:cNvPr id="9" name="Text 7">
+            <a:extLst>
+              <a:ext uri="{FF2B5EF4-FFF2-40B4-BE49-F238E27FC236}">
+                <a16:creationId xmlns:a16="http://schemas.microsoft.com/office/drawing/2014/main" id="{304CDB70-CD28-2423-A1AC-61821D13AB9B}"/>
+              </a:ext>
+            </a:extLst>
+          </p:cNvPr>
+          <p:cNvSpPr/>
+          <p:nvPr/>
+        </p:nvSpPr>
+        <p:spPr>
+          <a:xfrm>
+            <a:off x="1188720" y="2286000"/>
+            <a:ext cx="7406640" cy="320040"/>
+          </a:xfrm>
+          <a:prstGeom prst="rect">
+            <a:avLst/>
+          </a:prstGeom>
+          <a:noFill/>
+          <a:ln/>
+        </p:spPr>
+        <p:txBody>
+          <a:bodyPr wrap="square" lIns="0" tIns="0" rIns="0" bIns="0" rtlCol="0" anchor="ctr"/>
+          <a:lstStyle/>
+          <a:p>
+            <a:pPr marL="0" indent="0">
+              <a:buNone/>
+            </a:pPr>
+            <a:r>
+              <a:rPr lang="en-US" sz="1600" b="1" dirty="0">
+                <a:solidFill>
+                  <a:srgbClr val="1E2761"/>
+                </a:solidFill>
+                <a:latin typeface="Calibri" pitchFamily="34" charset="0"/>
+                <a:ea typeface="Calibri" pitchFamily="34" charset="-122"/>
+                <a:cs typeface="Calibri" pitchFamily="34" charset="-120"/>
+              </a:rPr>
+              <a:t>Concurrent LLM releases confound the GPT-4o effect</a:t>
+            </a:r>
+            <a:endParaRPr lang="en-US" sz="1600" dirty="0"/>
+          </a:p>
+        </p:txBody>
+      </p:sp>
+      <p:sp>
+        <p:nvSpPr>
+          <p:cNvPr id="10" name="Text 8">
+            <a:extLst>
+              <a:ext uri="{FF2B5EF4-FFF2-40B4-BE49-F238E27FC236}">
+                <a16:creationId xmlns:a16="http://schemas.microsoft.com/office/drawing/2014/main" id="{C7A8B87D-F053-33EF-6FCB-1B00172B8B59}"/>
+              </a:ext>
+            </a:extLst>
+          </p:cNvPr>
+          <p:cNvSpPr/>
+          <p:nvPr/>
+        </p:nvSpPr>
+        <p:spPr>
+          <a:xfrm>
+            <a:off x="1188720" y="2633472"/>
+            <a:ext cx="7406640" cy="594360"/>
+          </a:xfrm>
+          <a:prstGeom prst="rect">
+            <a:avLst/>
+          </a:prstGeom>
+          <a:noFill/>
+          <a:ln/>
+        </p:spPr>
+        <p:txBody>
+          <a:bodyPr wrap="square" lIns="0" tIns="0" rIns="0" bIns="0" rtlCol="0" anchor="ctr"/>
+          <a:lstStyle/>
+          <a:p>
+            <a:pPr marL="0" indent="0">
+              <a:buNone/>
+            </a:pPr>
+            <a:r>
+              <a:rPr lang="en-US" sz="1200" dirty="0">
+                <a:solidFill>
+                  <a:srgbClr val="1E2761"/>
+                </a:solidFill>
+                <a:latin typeface="Calibri" pitchFamily="34" charset="0"/>
+                <a:ea typeface="Calibri" pitchFamily="34" charset="-122"/>
+                <a:cs typeface="Calibri" pitchFamily="34" charset="-120"/>
+              </a:rPr>
+              <a:t>Claude, Gemini, and Llama improved over the same period. Our estimand is best interpreted as the effect of crossing a broad AI accessibility threshold — GPT-4o was the first frontier model available for free — not the effect of one product.</a:t>
+            </a:r>
+            <a:endParaRPr lang="en-US" sz="1200" dirty="0"/>
+          </a:p>
+        </p:txBody>
+      </p:sp>
+      <p:sp>
+        <p:nvSpPr>
+          <p:cNvPr id="11" name="Shape 9">
+            <a:extLst>
+              <a:ext uri="{FF2B5EF4-FFF2-40B4-BE49-F238E27FC236}">
+                <a16:creationId xmlns:a16="http://schemas.microsoft.com/office/drawing/2014/main" id="{B244D651-0B9D-EDC0-418F-8ED3F2928F98}"/>
+              </a:ext>
+            </a:extLst>
+          </p:cNvPr>
+          <p:cNvSpPr/>
+          <p:nvPr/>
+        </p:nvSpPr>
+        <p:spPr>
+          <a:xfrm>
+            <a:off x="548640" y="3474720"/>
+            <a:ext cx="411480" cy="411480"/>
+          </a:xfrm>
+          <a:prstGeom prst="ellipse">
+            <a:avLst/>
+          </a:prstGeom>
+          <a:solidFill>
+            <a:srgbClr val="3A7BD5"/>
+          </a:solidFill>
+          <a:ln/>
+        </p:spPr>
+        <p:txBody>
+          <a:bodyPr/>
+          <a:lstStyle/>
+          <a:p>
+            <a:endParaRPr lang="en-US"/>
+          </a:p>
+        </p:txBody>
+      </p:sp>
+      <p:sp>
+        <p:nvSpPr>
+          <p:cNvPr id="12" name="Text 10">
+            <a:extLst>
+              <a:ext uri="{FF2B5EF4-FFF2-40B4-BE49-F238E27FC236}">
+                <a16:creationId xmlns:a16="http://schemas.microsoft.com/office/drawing/2014/main" id="{04598254-BB29-D9AB-769E-B9F02B20CF05}"/>
+              </a:ext>
+            </a:extLst>
+          </p:cNvPr>
+          <p:cNvSpPr/>
+          <p:nvPr/>
+        </p:nvSpPr>
+        <p:spPr>
+          <a:xfrm>
+            <a:off x="548640" y="3474720"/>
+            <a:ext cx="411480" cy="411480"/>
+          </a:xfrm>
+          <a:prstGeom prst="rect">
+            <a:avLst/>
+          </a:prstGeom>
+          <a:noFill/>
+          <a:ln/>
+        </p:spPr>
+        <p:txBody>
+          <a:bodyPr wrap="square" rtlCol="0" anchor="ctr"/>
+          <a:lstStyle/>
+          <a:p>
+            <a:pPr marL="0" indent="0" algn="ctr">
+              <a:buNone/>
+            </a:pPr>
+            <a:r>
+              <a:rPr lang="en-US" sz="1600" b="1" dirty="0">
+                <a:solidFill>
+                  <a:srgbClr val="FFFFFF"/>
+                </a:solidFill>
+                <a:latin typeface="Calibri" pitchFamily="34" charset="0"/>
+                <a:ea typeface="Calibri" pitchFamily="34" charset="-122"/>
+                <a:cs typeface="Calibri" pitchFamily="34" charset="-120"/>
+              </a:rPr>
+              <a:t>3</a:t>
+            </a:r>
+            <a:endParaRPr lang="en-US" sz="1600" dirty="0"/>
+          </a:p>
+        </p:txBody>
+      </p:sp>
+      <p:sp>
+        <p:nvSpPr>
+          <p:cNvPr id="13" name="Text 11">
+            <a:extLst>
+              <a:ext uri="{FF2B5EF4-FFF2-40B4-BE49-F238E27FC236}">
+                <a16:creationId xmlns:a16="http://schemas.microsoft.com/office/drawing/2014/main" id="{6671BF55-9205-B595-60D7-A671BB5FDAEB}"/>
+              </a:ext>
+            </a:extLst>
+          </p:cNvPr>
+          <p:cNvSpPr/>
+          <p:nvPr/>
+        </p:nvSpPr>
+        <p:spPr>
+          <a:xfrm>
+            <a:off x="1188720" y="3474720"/>
+            <a:ext cx="7406640" cy="320040"/>
+          </a:xfrm>
+          <a:prstGeom prst="rect">
+            <a:avLst/>
+          </a:prstGeom>
+          <a:noFill/>
+          <a:ln/>
+        </p:spPr>
+        <p:txBody>
+          <a:bodyPr wrap="square" lIns="0" tIns="0" rIns="0" bIns="0" rtlCol="0" anchor="ctr"/>
+          <a:lstStyle/>
+          <a:p>
+            <a:pPr marL="0" indent="0">
+              <a:buNone/>
+            </a:pPr>
+            <a:r>
+              <a:rPr lang="en-US" sz="1600" b="1" dirty="0">
+                <a:solidFill>
+                  <a:srgbClr val="1E2761"/>
+                </a:solidFill>
+                <a:latin typeface="Calibri" pitchFamily="34" charset="0"/>
+                <a:ea typeface="Calibri" pitchFamily="34" charset="-122"/>
+                <a:cs typeface="Calibri" pitchFamily="34" charset="-120"/>
+              </a:rPr>
+              <a:t>Propensity reflects field structure, not individual behavior</a:t>
+            </a:r>
+            <a:endParaRPr lang="en-US" sz="1600" dirty="0"/>
+          </a:p>
+        </p:txBody>
+      </p:sp>
+      <p:sp>
+        <p:nvSpPr>
+          <p:cNvPr id="14" name="Text 12">
+            <a:extLst>
+              <a:ext uri="{FF2B5EF4-FFF2-40B4-BE49-F238E27FC236}">
+                <a16:creationId xmlns:a16="http://schemas.microsoft.com/office/drawing/2014/main" id="{D47E09DE-66E3-FE3F-1059-54D5E6AB83F5}"/>
+              </a:ext>
+            </a:extLst>
+          </p:cNvPr>
+          <p:cNvSpPr/>
+          <p:nvPr/>
+        </p:nvSpPr>
+        <p:spPr>
+          <a:xfrm>
+            <a:off x="1188720" y="3822192"/>
+            <a:ext cx="7406640" cy="685800"/>
+          </a:xfrm>
+          <a:prstGeom prst="rect">
+            <a:avLst/>
+          </a:prstGeom>
+          <a:noFill/>
+          <a:ln/>
+        </p:spPr>
+        <p:txBody>
+          <a:bodyPr wrap="square" lIns="0" tIns="0" rIns="0" bIns="0" rtlCol="0" anchor="ctr"/>
+          <a:lstStyle/>
+          <a:p>
+            <a:pPr marL="0" indent="0">
+              <a:buNone/>
+            </a:pPr>
+            <a:r>
+              <a:rPr lang="en-US" sz="1200" dirty="0">
+                <a:solidFill>
+                  <a:srgbClr val="1E2761"/>
+                </a:solidFill>
+                <a:latin typeface="Calibri" pitchFamily="34" charset="0"/>
+                <a:ea typeface="Calibri" pitchFamily="34" charset="-122"/>
+                <a:cs typeface="Calibri" pitchFamily="34" charset="-120"/>
+              </a:rPr>
+              <a:t>We cannot distinguish whether high-propensity fields adopt LLMs because of structural workflow amenability or because of demographic composition (e.g., younger, more tech-savvy researchers). Field FE absorb level differences, but the interaction could still reflect composition.</a:t>
+            </a:r>
+            <a:endParaRPr lang="en-US" sz="1200" dirty="0"/>
+          </a:p>
+        </p:txBody>
+      </p:sp>
+    </p:spTree>
+    <p:extLst>
+      <p:ext uri="{BB962C8B-B14F-4D97-AF65-F5344CB8AC3E}">
+        <p14:creationId xmlns:p14="http://schemas.microsoft.com/office/powerpoint/2010/main" val="3067539919"/>
+      </p:ext>
+    </p:extLst>
+  </p:cSld>
+  <p:clrMapOvr>
+    <a:masterClrMapping/>
+  </p:clrMapOvr>
+</p:sld>
+</file>
+
+<file path=ppt/slides/slide17.xml><?xml version="1.0" encoding="utf-8"?>
 <p:sld xmlns:a="http://schemas.openxmlformats.org/drawingml/2006/main" xmlns:r="http://schemas.openxmlformats.org/officeDocument/2006/relationships" xmlns:p="http://schemas.openxmlformats.org/presentationml/2006/main">
   <p:cSld name="Slide 10">
     <p:bg>
@@ -6703,7 +8108,7 @@
 </p:sld>
 </file>
 
-<file path=ppt/slides/slide16.xml><?xml version="1.0" encoding="utf-8"?>
+<file path=ppt/slides/slide18.xml><?xml version="1.0" encoding="utf-8"?>
 <p:sld xmlns:a="http://schemas.openxmlformats.org/drawingml/2006/main" xmlns:r="http://schemas.openxmlformats.org/officeDocument/2006/relationships" xmlns:p="http://schemas.openxmlformats.org/presentationml/2006/main">
   <p:cSld>
     <p:bg>
@@ -7170,7 +8575,7 @@
 </p:sld>
 </file>
 
-<file path=ppt/slides/slide17.xml><?xml version="1.0" encoding="utf-8"?>
+<file path=ppt/slides/slide19.xml><?xml version="1.0" encoding="utf-8"?>
 <p:sld xmlns:a="http://schemas.openxmlformats.org/drawingml/2006/main" xmlns:r="http://schemas.openxmlformats.org/officeDocument/2006/relationships" xmlns:p="http://schemas.openxmlformats.org/presentationml/2006/main">
   <p:cSld>
     <p:bg>
@@ -7801,1131 +9206,6 @@
         <p14:creationId xmlns:p14="http://schemas.microsoft.com/office/powerpoint/2010/main" val="3932410957"/>
       </p:ext>
     </p:extLst>
-  </p:cSld>
-  <p:clrMapOvr>
-    <a:masterClrMapping/>
-  </p:clrMapOvr>
-</p:sld>
-</file>
-
-<file path=ppt/slides/slide18.xml><?xml version="1.0" encoding="utf-8"?>
-<p:sld xmlns:a="http://schemas.openxmlformats.org/drawingml/2006/main" xmlns:r="http://schemas.openxmlformats.org/officeDocument/2006/relationships" xmlns:p="http://schemas.openxmlformats.org/presentationml/2006/main">
-  <p:cSld>
-    <p:bg>
-      <p:bgPr>
-        <a:solidFill>
-          <a:srgbClr val="1E2761"/>
-        </a:solidFill>
-        <a:effectLst/>
-      </p:bgPr>
-    </p:bg>
-    <p:spTree>
-      <p:nvGrpSpPr>
-        <p:cNvPr id="1" name="">
-          <a:extLst>
-            <a:ext uri="{FF2B5EF4-FFF2-40B4-BE49-F238E27FC236}">
-              <a16:creationId xmlns:a16="http://schemas.microsoft.com/office/drawing/2014/main" id="{017323DF-F73E-73C8-ED03-ADE3BBAE66EB}"/>
-            </a:ext>
-          </a:extLst>
-        </p:cNvPr>
-        <p:cNvGrpSpPr/>
-        <p:nvPr/>
-      </p:nvGrpSpPr>
-      <p:grpSpPr>
-        <a:xfrm>
-          <a:off x="0" y="0"/>
-          <a:ext cx="0" cy="0"/>
-          <a:chOff x="0" y="0"/>
-          <a:chExt cx="0" cy="0"/>
-        </a:xfrm>
-      </p:grpSpPr>
-      <p:sp>
-        <p:nvSpPr>
-          <p:cNvPr id="2" name="Text 0">
-            <a:extLst>
-              <a:ext uri="{FF2B5EF4-FFF2-40B4-BE49-F238E27FC236}">
-                <a16:creationId xmlns:a16="http://schemas.microsoft.com/office/drawing/2014/main" id="{9B3884E1-EA25-66BB-D7E8-702E2351DEE9}"/>
-              </a:ext>
-            </a:extLst>
-          </p:cNvPr>
-          <p:cNvSpPr/>
-          <p:nvPr/>
-        </p:nvSpPr>
-        <p:spPr>
-          <a:xfrm>
-            <a:off x="731520" y="365760"/>
-            <a:ext cx="7680960" cy="640080"/>
-          </a:xfrm>
-          <a:prstGeom prst="rect">
-            <a:avLst/>
-          </a:prstGeom>
-          <a:noFill/>
-          <a:ln/>
-        </p:spPr>
-        <p:txBody>
-          <a:bodyPr wrap="square" lIns="0" tIns="0" rIns="0" bIns="0" rtlCol="0" anchor="ctr"/>
-          <a:lstStyle/>
-          <a:p>
-            <a:pPr marL="0" indent="0">
-              <a:buNone/>
-            </a:pPr>
-            <a:r>
-              <a:rPr lang="en-US" sz="3200" b="1" dirty="0">
-                <a:solidFill>
-                  <a:srgbClr val="FFFFFF"/>
-                </a:solidFill>
-                <a:latin typeface="Georgia" pitchFamily="34" charset="0"/>
-                <a:ea typeface="Georgia" pitchFamily="34" charset="-122"/>
-                <a:cs typeface="Georgia" pitchFamily="34" charset="-120"/>
-              </a:rPr>
-              <a:t>Key Takeaways</a:t>
-            </a:r>
-            <a:endParaRPr lang="en-US" sz="3200" dirty="0"/>
-          </a:p>
-        </p:txBody>
-      </p:sp>
-      <p:sp>
-        <p:nvSpPr>
-          <p:cNvPr id="3" name="Shape 1">
-            <a:extLst>
-              <a:ext uri="{FF2B5EF4-FFF2-40B4-BE49-F238E27FC236}">
-                <a16:creationId xmlns:a16="http://schemas.microsoft.com/office/drawing/2014/main" id="{781AC0B1-C8DB-8133-B709-786CE84206A3}"/>
-              </a:ext>
-            </a:extLst>
-          </p:cNvPr>
-          <p:cNvSpPr/>
-          <p:nvPr/>
-        </p:nvSpPr>
-        <p:spPr>
-          <a:xfrm>
-            <a:off x="731520" y="1280160"/>
-            <a:ext cx="411480" cy="411480"/>
-          </a:xfrm>
-          <a:prstGeom prst="ellipse">
-            <a:avLst/>
-          </a:prstGeom>
-          <a:solidFill>
-            <a:srgbClr val="3A7BD5"/>
-          </a:solidFill>
-          <a:ln/>
-        </p:spPr>
-        <p:txBody>
-          <a:bodyPr/>
-          <a:lstStyle/>
-          <a:p>
-            <a:endParaRPr lang="en-US"/>
-          </a:p>
-        </p:txBody>
-      </p:sp>
-      <p:sp>
-        <p:nvSpPr>
-          <p:cNvPr id="4" name="Text 2">
-            <a:extLst>
-              <a:ext uri="{FF2B5EF4-FFF2-40B4-BE49-F238E27FC236}">
-                <a16:creationId xmlns:a16="http://schemas.microsoft.com/office/drawing/2014/main" id="{ACAE4663-2783-282D-5B4C-1964528CD493}"/>
-              </a:ext>
-            </a:extLst>
-          </p:cNvPr>
-          <p:cNvSpPr/>
-          <p:nvPr/>
-        </p:nvSpPr>
-        <p:spPr>
-          <a:xfrm>
-            <a:off x="731520" y="1280160"/>
-            <a:ext cx="411480" cy="411480"/>
-          </a:xfrm>
-          <a:prstGeom prst="rect">
-            <a:avLst/>
-          </a:prstGeom>
-          <a:noFill/>
-          <a:ln/>
-        </p:spPr>
-        <p:txBody>
-          <a:bodyPr wrap="square" rtlCol="0" anchor="ctr"/>
-          <a:lstStyle/>
-          <a:p>
-            <a:pPr marL="0" indent="0" algn="ctr">
-              <a:buNone/>
-            </a:pPr>
-            <a:r>
-              <a:rPr lang="en-US" sz="1600" b="1" dirty="0">
-                <a:solidFill>
-                  <a:srgbClr val="FFFFFF"/>
-                </a:solidFill>
-                <a:latin typeface="Calibri" pitchFamily="34" charset="0"/>
-                <a:ea typeface="Calibri" pitchFamily="34" charset="-122"/>
-                <a:cs typeface="Calibri" pitchFamily="34" charset="-120"/>
-              </a:rPr>
-              <a:t>1</a:t>
-            </a:r>
-            <a:endParaRPr lang="en-US" sz="1600" dirty="0"/>
-          </a:p>
-        </p:txBody>
-      </p:sp>
-      <p:sp>
-        <p:nvSpPr>
-          <p:cNvPr id="5" name="Text 3">
-            <a:extLst>
-              <a:ext uri="{FF2B5EF4-FFF2-40B4-BE49-F238E27FC236}">
-                <a16:creationId xmlns:a16="http://schemas.microsoft.com/office/drawing/2014/main" id="{03F29060-F554-DF50-3B22-DA5ADA16DF29}"/>
-              </a:ext>
-            </a:extLst>
-          </p:cNvPr>
-          <p:cNvSpPr/>
-          <p:nvPr/>
-        </p:nvSpPr>
-        <p:spPr>
-          <a:xfrm>
-            <a:off x="1371600" y="1234440"/>
-            <a:ext cx="7040880" cy="320040"/>
-          </a:xfrm>
-          <a:prstGeom prst="rect">
-            <a:avLst/>
-          </a:prstGeom>
-          <a:noFill/>
-          <a:ln/>
-        </p:spPr>
-        <p:txBody>
-          <a:bodyPr wrap="square" lIns="0" tIns="0" rIns="0" bIns="0" rtlCol="0" anchor="ctr"/>
-          <a:lstStyle/>
-          <a:p>
-            <a:pPr marL="0" indent="0">
-              <a:buNone/>
-            </a:pPr>
-            <a:r>
-              <a:rPr lang="en-US" sz="1600" b="1" dirty="0">
-                <a:solidFill>
-                  <a:srgbClr val="FFFFFF"/>
-                </a:solidFill>
-                <a:latin typeface="Calibri" pitchFamily="34" charset="0"/>
-                <a:ea typeface="Calibri" pitchFamily="34" charset="-122"/>
-                <a:cs typeface="Calibri" pitchFamily="34" charset="-120"/>
-              </a:rPr>
-              <a:t>LLM Adoption Causes an Increase in Citation Diversity </a:t>
-            </a:r>
-            <a:endParaRPr lang="en-US" sz="1600" dirty="0"/>
-          </a:p>
-        </p:txBody>
-      </p:sp>
-      <p:sp>
-        <p:nvSpPr>
-          <p:cNvPr id="6" name="Text 4">
-            <a:extLst>
-              <a:ext uri="{FF2B5EF4-FFF2-40B4-BE49-F238E27FC236}">
-                <a16:creationId xmlns:a16="http://schemas.microsoft.com/office/drawing/2014/main" id="{F7B80644-6101-89A2-DA26-4D5B01023908}"/>
-              </a:ext>
-            </a:extLst>
-          </p:cNvPr>
-          <p:cNvSpPr/>
-          <p:nvPr/>
-        </p:nvSpPr>
-        <p:spPr>
-          <a:xfrm>
-            <a:off x="1371600" y="1554480"/>
-            <a:ext cx="7040880" cy="411480"/>
-          </a:xfrm>
-          <a:prstGeom prst="rect">
-            <a:avLst/>
-          </a:prstGeom>
-          <a:noFill/>
-          <a:ln/>
-        </p:spPr>
-        <p:txBody>
-          <a:bodyPr wrap="square" lIns="0" tIns="0" rIns="0" bIns="0" rtlCol="0" anchor="ctr"/>
-          <a:lstStyle/>
-          <a:p>
-            <a:pPr marL="0" indent="0">
-              <a:buNone/>
-            </a:pPr>
-            <a:r>
-              <a:rPr lang="en-US" sz="1200" dirty="0">
-                <a:solidFill>
-                  <a:srgbClr val="CADCFC"/>
-                </a:solidFill>
-                <a:latin typeface="Calibri" pitchFamily="34" charset="0"/>
-                <a:ea typeface="Calibri" pitchFamily="34" charset="-122"/>
-                <a:cs typeface="Calibri" pitchFamily="34" charset="-120"/>
-              </a:rPr>
-              <a:t>Shannon entropy increases by +0.031 nats/month in high-propensity fields post-4o. This is a robust finding.</a:t>
-            </a:r>
-            <a:endParaRPr lang="en-US" sz="1200" dirty="0"/>
-          </a:p>
-        </p:txBody>
-      </p:sp>
-      <p:sp>
-        <p:nvSpPr>
-          <p:cNvPr id="7" name="Shape 5">
-            <a:extLst>
-              <a:ext uri="{FF2B5EF4-FFF2-40B4-BE49-F238E27FC236}">
-                <a16:creationId xmlns:a16="http://schemas.microsoft.com/office/drawing/2014/main" id="{8A239DFF-2A49-53C8-6450-89495E6D1576}"/>
-              </a:ext>
-            </a:extLst>
-          </p:cNvPr>
-          <p:cNvSpPr/>
-          <p:nvPr/>
-        </p:nvSpPr>
-        <p:spPr>
-          <a:xfrm>
-            <a:off x="731520" y="2194560"/>
-            <a:ext cx="411480" cy="411480"/>
-          </a:xfrm>
-          <a:prstGeom prst="ellipse">
-            <a:avLst/>
-          </a:prstGeom>
-          <a:solidFill>
-            <a:srgbClr val="3A7BD5"/>
-          </a:solidFill>
-          <a:ln/>
-        </p:spPr>
-        <p:txBody>
-          <a:bodyPr/>
-          <a:lstStyle/>
-          <a:p>
-            <a:endParaRPr lang="en-US"/>
-          </a:p>
-        </p:txBody>
-      </p:sp>
-      <p:sp>
-        <p:nvSpPr>
-          <p:cNvPr id="8" name="Text 6">
-            <a:extLst>
-              <a:ext uri="{FF2B5EF4-FFF2-40B4-BE49-F238E27FC236}">
-                <a16:creationId xmlns:a16="http://schemas.microsoft.com/office/drawing/2014/main" id="{BFB364C2-7EE0-8596-F287-696052348DA3}"/>
-              </a:ext>
-            </a:extLst>
-          </p:cNvPr>
-          <p:cNvSpPr/>
-          <p:nvPr/>
-        </p:nvSpPr>
-        <p:spPr>
-          <a:xfrm>
-            <a:off x="731520" y="2194560"/>
-            <a:ext cx="411480" cy="411480"/>
-          </a:xfrm>
-          <a:prstGeom prst="rect">
-            <a:avLst/>
-          </a:prstGeom>
-          <a:noFill/>
-          <a:ln/>
-        </p:spPr>
-        <p:txBody>
-          <a:bodyPr wrap="square" rtlCol="0" anchor="ctr"/>
-          <a:lstStyle/>
-          <a:p>
-            <a:pPr marL="0" indent="0" algn="ctr">
-              <a:buNone/>
-            </a:pPr>
-            <a:r>
-              <a:rPr lang="en-US" sz="1600" b="1" dirty="0">
-                <a:solidFill>
-                  <a:srgbClr val="FFFFFF"/>
-                </a:solidFill>
-                <a:latin typeface="Calibri" pitchFamily="34" charset="0"/>
-                <a:ea typeface="Calibri" pitchFamily="34" charset="-122"/>
-                <a:cs typeface="Calibri" pitchFamily="34" charset="-120"/>
-              </a:rPr>
-              <a:t>2</a:t>
-            </a:r>
-            <a:endParaRPr lang="en-US" sz="1600" dirty="0"/>
-          </a:p>
-        </p:txBody>
-      </p:sp>
-      <p:sp>
-        <p:nvSpPr>
-          <p:cNvPr id="9" name="Text 7">
-            <a:extLst>
-              <a:ext uri="{FF2B5EF4-FFF2-40B4-BE49-F238E27FC236}">
-                <a16:creationId xmlns:a16="http://schemas.microsoft.com/office/drawing/2014/main" id="{E8ACE3D1-402E-0BE3-422D-5D8E4907CDA5}"/>
-              </a:ext>
-            </a:extLst>
-          </p:cNvPr>
-          <p:cNvSpPr/>
-          <p:nvPr/>
-        </p:nvSpPr>
-        <p:spPr>
-          <a:xfrm>
-            <a:off x="1371600" y="2148840"/>
-            <a:ext cx="7040880" cy="320040"/>
-          </a:xfrm>
-          <a:prstGeom prst="rect">
-            <a:avLst/>
-          </a:prstGeom>
-          <a:noFill/>
-          <a:ln/>
-        </p:spPr>
-        <p:txBody>
-          <a:bodyPr wrap="square" lIns="0" tIns="0" rIns="0" bIns="0" rtlCol="0" anchor="ctr"/>
-          <a:lstStyle/>
-          <a:p>
-            <a:pPr marL="0" indent="0">
-              <a:buNone/>
-            </a:pPr>
-            <a:r>
-              <a:rPr lang="en-US" sz="1600" b="1" dirty="0">
-                <a:solidFill>
-                  <a:srgbClr val="FFFFFF"/>
-                </a:solidFill>
-                <a:latin typeface="Calibri" pitchFamily="34" charset="0"/>
-                <a:ea typeface="Calibri" pitchFamily="34" charset="-122"/>
-                <a:cs typeface="Calibri" pitchFamily="34" charset="-120"/>
-              </a:rPr>
-              <a:t>Effect is gradual, not a jump</a:t>
-            </a:r>
-            <a:endParaRPr lang="en-US" sz="1600" dirty="0"/>
-          </a:p>
-        </p:txBody>
-      </p:sp>
-      <p:sp>
-        <p:nvSpPr>
-          <p:cNvPr id="10" name="Text 8">
-            <a:extLst>
-              <a:ext uri="{FF2B5EF4-FFF2-40B4-BE49-F238E27FC236}">
-                <a16:creationId xmlns:a16="http://schemas.microsoft.com/office/drawing/2014/main" id="{A20BEF4E-FCC6-DBDD-8701-93F0D586F723}"/>
-              </a:ext>
-            </a:extLst>
-          </p:cNvPr>
-          <p:cNvSpPr/>
-          <p:nvPr/>
-        </p:nvSpPr>
-        <p:spPr>
-          <a:xfrm>
-            <a:off x="1371600" y="2468880"/>
-            <a:ext cx="7040880" cy="411480"/>
-          </a:xfrm>
-          <a:prstGeom prst="rect">
-            <a:avLst/>
-          </a:prstGeom>
-          <a:noFill/>
-          <a:ln/>
-        </p:spPr>
-        <p:txBody>
-          <a:bodyPr wrap="square" lIns="0" tIns="0" rIns="0" bIns="0" rtlCol="0" anchor="ctr"/>
-          <a:lstStyle/>
-          <a:p>
-            <a:pPr marL="0" indent="0">
-              <a:buNone/>
-            </a:pPr>
-            <a:r>
-              <a:rPr lang="en-US" sz="1200" dirty="0">
-                <a:solidFill>
-                  <a:srgbClr val="CADCFC"/>
-                </a:solidFill>
-                <a:latin typeface="Calibri" pitchFamily="34" charset="0"/>
-                <a:ea typeface="Calibri" pitchFamily="34" charset="-122"/>
-                <a:cs typeface="Calibri" pitchFamily="34" charset="-120"/>
-              </a:rPr>
-              <a:t>Treatment × trend specification fits better than level shift — consistent with diffusion</a:t>
-            </a:r>
-            <a:endParaRPr lang="en-US" sz="1200" dirty="0"/>
-          </a:p>
-        </p:txBody>
-      </p:sp>
-      <p:sp>
-        <p:nvSpPr>
-          <p:cNvPr id="11" name="Shape 9">
-            <a:extLst>
-              <a:ext uri="{FF2B5EF4-FFF2-40B4-BE49-F238E27FC236}">
-                <a16:creationId xmlns:a16="http://schemas.microsoft.com/office/drawing/2014/main" id="{E04492E1-BF96-E02C-461D-68ECEF96F55A}"/>
-              </a:ext>
-            </a:extLst>
-          </p:cNvPr>
-          <p:cNvSpPr/>
-          <p:nvPr/>
-        </p:nvSpPr>
-        <p:spPr>
-          <a:xfrm>
-            <a:off x="731520" y="3108960"/>
-            <a:ext cx="411480" cy="411480"/>
-          </a:xfrm>
-          <a:prstGeom prst="ellipse">
-            <a:avLst/>
-          </a:prstGeom>
-          <a:solidFill>
-            <a:srgbClr val="3A7BD5"/>
-          </a:solidFill>
-          <a:ln/>
-        </p:spPr>
-        <p:txBody>
-          <a:bodyPr/>
-          <a:lstStyle/>
-          <a:p>
-            <a:endParaRPr lang="en-US"/>
-          </a:p>
-        </p:txBody>
-      </p:sp>
-      <p:sp>
-        <p:nvSpPr>
-          <p:cNvPr id="12" name="Text 10">
-            <a:extLst>
-              <a:ext uri="{FF2B5EF4-FFF2-40B4-BE49-F238E27FC236}">
-                <a16:creationId xmlns:a16="http://schemas.microsoft.com/office/drawing/2014/main" id="{6EA824BD-9369-0B4B-7819-14AFEC9D69B4}"/>
-              </a:ext>
-            </a:extLst>
-          </p:cNvPr>
-          <p:cNvSpPr/>
-          <p:nvPr/>
-        </p:nvSpPr>
-        <p:spPr>
-          <a:xfrm>
-            <a:off x="731520" y="3108960"/>
-            <a:ext cx="411480" cy="411480"/>
-          </a:xfrm>
-          <a:prstGeom prst="rect">
-            <a:avLst/>
-          </a:prstGeom>
-          <a:noFill/>
-          <a:ln/>
-        </p:spPr>
-        <p:txBody>
-          <a:bodyPr wrap="square" rtlCol="0" anchor="ctr"/>
-          <a:lstStyle/>
-          <a:p>
-            <a:pPr marL="0" indent="0" algn="ctr">
-              <a:buNone/>
-            </a:pPr>
-            <a:r>
-              <a:rPr lang="en-US" sz="1600" b="1" dirty="0">
-                <a:solidFill>
-                  <a:srgbClr val="FFFFFF"/>
-                </a:solidFill>
-                <a:latin typeface="Calibri" pitchFamily="34" charset="0"/>
-                <a:ea typeface="Calibri" pitchFamily="34" charset="-122"/>
-                <a:cs typeface="Calibri" pitchFamily="34" charset="-120"/>
-              </a:rPr>
-              <a:t>3</a:t>
-            </a:r>
-            <a:endParaRPr lang="en-US" sz="1600" dirty="0"/>
-          </a:p>
-        </p:txBody>
-      </p:sp>
-      <p:sp>
-        <p:nvSpPr>
-          <p:cNvPr id="13" name="Text 11">
-            <a:extLst>
-              <a:ext uri="{FF2B5EF4-FFF2-40B4-BE49-F238E27FC236}">
-                <a16:creationId xmlns:a16="http://schemas.microsoft.com/office/drawing/2014/main" id="{6C645505-5D25-92E7-5830-40E37DEF4ED8}"/>
-              </a:ext>
-            </a:extLst>
-          </p:cNvPr>
-          <p:cNvSpPr/>
-          <p:nvPr/>
-        </p:nvSpPr>
-        <p:spPr>
-          <a:xfrm>
-            <a:off x="1371600" y="3063240"/>
-            <a:ext cx="7040880" cy="320040"/>
-          </a:xfrm>
-          <a:prstGeom prst="rect">
-            <a:avLst/>
-          </a:prstGeom>
-          <a:noFill/>
-          <a:ln/>
-        </p:spPr>
-        <p:txBody>
-          <a:bodyPr wrap="square" lIns="0" tIns="0" rIns="0" bIns="0" rtlCol="0" anchor="ctr"/>
-          <a:lstStyle/>
-          <a:p>
-            <a:pPr marL="0" indent="0">
-              <a:buNone/>
-            </a:pPr>
-            <a:r>
-              <a:rPr lang="en-US" sz="1600" b="1" dirty="0">
-                <a:solidFill>
-                  <a:srgbClr val="FFFFFF"/>
-                </a:solidFill>
-                <a:latin typeface="Calibri" pitchFamily="34" charset="0"/>
-                <a:ea typeface="Calibri" pitchFamily="34" charset="-122"/>
-                <a:cs typeface="Calibri" pitchFamily="34" charset="-120"/>
-              </a:rPr>
-              <a:t>Consistent across measures</a:t>
-            </a:r>
-            <a:endParaRPr lang="en-US" sz="1600" dirty="0"/>
-          </a:p>
-        </p:txBody>
-      </p:sp>
-      <p:sp>
-        <p:nvSpPr>
-          <p:cNvPr id="14" name="Text 12">
-            <a:extLst>
-              <a:ext uri="{FF2B5EF4-FFF2-40B4-BE49-F238E27FC236}">
-                <a16:creationId xmlns:a16="http://schemas.microsoft.com/office/drawing/2014/main" id="{159C799E-0C6C-323C-4BB6-108BB1D33D51}"/>
-              </a:ext>
-            </a:extLst>
-          </p:cNvPr>
-          <p:cNvSpPr/>
-          <p:nvPr/>
-        </p:nvSpPr>
-        <p:spPr>
-          <a:xfrm>
-            <a:off x="1371600" y="3383280"/>
-            <a:ext cx="7040880" cy="411480"/>
-          </a:xfrm>
-          <a:prstGeom prst="rect">
-            <a:avLst/>
-          </a:prstGeom>
-          <a:noFill/>
-          <a:ln/>
-        </p:spPr>
-        <p:txBody>
-          <a:bodyPr wrap="square" lIns="0" tIns="0" rIns="0" bIns="0" rtlCol="0" anchor="ctr"/>
-          <a:lstStyle/>
-          <a:p>
-            <a:r>
-              <a:rPr lang="en-US" sz="1200" dirty="0">
-                <a:solidFill>
-                  <a:srgbClr val="CADCFC"/>
-                </a:solidFill>
-                <a:latin typeface="Calibri" pitchFamily="34" charset="0"/>
-                <a:ea typeface="Calibri" pitchFamily="34" charset="-122"/>
-                <a:cs typeface="Calibri" pitchFamily="34" charset="-120"/>
-              </a:rPr>
-              <a:t>Entropy, distinct fields cited, and within-field share all point the same direction</a:t>
-            </a:r>
-            <a:endParaRPr lang="en-US" sz="1200" dirty="0"/>
-          </a:p>
-        </p:txBody>
-      </p:sp>
-      <p:sp>
-        <p:nvSpPr>
-          <p:cNvPr id="15" name="Shape 13">
-            <a:extLst>
-              <a:ext uri="{FF2B5EF4-FFF2-40B4-BE49-F238E27FC236}">
-                <a16:creationId xmlns:a16="http://schemas.microsoft.com/office/drawing/2014/main" id="{36EC8B2C-78F2-849A-66EC-326F3396AB90}"/>
-              </a:ext>
-            </a:extLst>
-          </p:cNvPr>
-          <p:cNvSpPr/>
-          <p:nvPr/>
-        </p:nvSpPr>
-        <p:spPr>
-          <a:xfrm>
-            <a:off x="731520" y="4023360"/>
-            <a:ext cx="411480" cy="411480"/>
-          </a:xfrm>
-          <a:prstGeom prst="ellipse">
-            <a:avLst/>
-          </a:prstGeom>
-          <a:solidFill>
-            <a:srgbClr val="3A7BD5"/>
-          </a:solidFill>
-          <a:ln/>
-        </p:spPr>
-        <p:txBody>
-          <a:bodyPr/>
-          <a:lstStyle/>
-          <a:p>
-            <a:endParaRPr lang="en-US"/>
-          </a:p>
-        </p:txBody>
-      </p:sp>
-      <p:sp>
-        <p:nvSpPr>
-          <p:cNvPr id="16" name="Text 14">
-            <a:extLst>
-              <a:ext uri="{FF2B5EF4-FFF2-40B4-BE49-F238E27FC236}">
-                <a16:creationId xmlns:a16="http://schemas.microsoft.com/office/drawing/2014/main" id="{CE633D03-77B6-2594-460B-8271162B5034}"/>
-              </a:ext>
-            </a:extLst>
-          </p:cNvPr>
-          <p:cNvSpPr/>
-          <p:nvPr/>
-        </p:nvSpPr>
-        <p:spPr>
-          <a:xfrm>
-            <a:off x="731520" y="4023360"/>
-            <a:ext cx="411480" cy="411480"/>
-          </a:xfrm>
-          <a:prstGeom prst="rect">
-            <a:avLst/>
-          </a:prstGeom>
-          <a:noFill/>
-          <a:ln/>
-        </p:spPr>
-        <p:txBody>
-          <a:bodyPr wrap="square" rtlCol="0" anchor="ctr"/>
-          <a:lstStyle/>
-          <a:p>
-            <a:pPr marL="0" indent="0" algn="ctr">
-              <a:buNone/>
-            </a:pPr>
-            <a:r>
-              <a:rPr lang="en-US" sz="1600" b="1" dirty="0">
-                <a:solidFill>
-                  <a:srgbClr val="FFFFFF"/>
-                </a:solidFill>
-                <a:latin typeface="Calibri" pitchFamily="34" charset="0"/>
-                <a:ea typeface="Calibri" pitchFamily="34" charset="-122"/>
-                <a:cs typeface="Calibri" pitchFamily="34" charset="-120"/>
-              </a:rPr>
-              <a:t>4</a:t>
-            </a:r>
-            <a:endParaRPr lang="en-US" sz="1600" dirty="0"/>
-          </a:p>
-        </p:txBody>
-      </p:sp>
-      <p:sp>
-        <p:nvSpPr>
-          <p:cNvPr id="17" name="Text 15">
-            <a:extLst>
-              <a:ext uri="{FF2B5EF4-FFF2-40B4-BE49-F238E27FC236}">
-                <a16:creationId xmlns:a16="http://schemas.microsoft.com/office/drawing/2014/main" id="{67B7BFED-8797-AF2E-127E-2983B893AE2C}"/>
-              </a:ext>
-            </a:extLst>
-          </p:cNvPr>
-          <p:cNvSpPr/>
-          <p:nvPr/>
-        </p:nvSpPr>
-        <p:spPr>
-          <a:xfrm>
-            <a:off x="1371600" y="3977640"/>
-            <a:ext cx="7040880" cy="320040"/>
-          </a:xfrm>
-          <a:prstGeom prst="rect">
-            <a:avLst/>
-          </a:prstGeom>
-          <a:noFill/>
-          <a:ln/>
-        </p:spPr>
-        <p:txBody>
-          <a:bodyPr wrap="square" lIns="0" tIns="0" rIns="0" bIns="0" rtlCol="0" anchor="ctr"/>
-          <a:lstStyle/>
-          <a:p>
-            <a:pPr marL="0" indent="0">
-              <a:buNone/>
-            </a:pPr>
-            <a:r>
-              <a:rPr lang="en-US" sz="1600" b="1" dirty="0">
-                <a:solidFill>
-                  <a:srgbClr val="FFFFFF"/>
-                </a:solidFill>
-                <a:latin typeface="Calibri" pitchFamily="34" charset="0"/>
-                <a:ea typeface="Calibri" pitchFamily="34" charset="-122"/>
-                <a:cs typeface="Calibri" pitchFamily="34" charset="-120"/>
-              </a:rPr>
-              <a:t>Complements existing literature</a:t>
-            </a:r>
-            <a:endParaRPr lang="en-US" sz="1600" dirty="0"/>
-          </a:p>
-        </p:txBody>
-      </p:sp>
-      <p:sp>
-        <p:nvSpPr>
-          <p:cNvPr id="18" name="Text 16">
-            <a:extLst>
-              <a:ext uri="{FF2B5EF4-FFF2-40B4-BE49-F238E27FC236}">
-                <a16:creationId xmlns:a16="http://schemas.microsoft.com/office/drawing/2014/main" id="{BB156AA3-BE2D-7991-2643-1BFEC69EBF12}"/>
-              </a:ext>
-            </a:extLst>
-          </p:cNvPr>
-          <p:cNvSpPr/>
-          <p:nvPr/>
-        </p:nvSpPr>
-        <p:spPr>
-          <a:xfrm>
-            <a:off x="1371600" y="4297680"/>
-            <a:ext cx="7040880" cy="411480"/>
-          </a:xfrm>
-          <a:prstGeom prst="rect">
-            <a:avLst/>
-          </a:prstGeom>
-          <a:noFill/>
-          <a:ln/>
-        </p:spPr>
-        <p:txBody>
-          <a:bodyPr wrap="square" lIns="0" tIns="0" rIns="0" bIns="0" rtlCol="0" anchor="ctr"/>
-          <a:lstStyle/>
-          <a:p>
-            <a:pPr marL="0" indent="0">
-              <a:buNone/>
-            </a:pPr>
-            <a:r>
-              <a:rPr lang="en-US" sz="1200" dirty="0">
-                <a:solidFill>
-                  <a:srgbClr val="CADCFC"/>
-                </a:solidFill>
-                <a:latin typeface="Calibri" pitchFamily="34" charset="0"/>
-                <a:ea typeface="Calibri" pitchFamily="34" charset="-122"/>
-                <a:cs typeface="Calibri" pitchFamily="34" charset="-120"/>
-              </a:rPr>
-              <a:t>Hao et al. (2026) find AI contracts knowledge extent; we find it expands citation breadth — different margins</a:t>
-            </a:r>
-            <a:endParaRPr lang="en-US" sz="1200" dirty="0"/>
-          </a:p>
-        </p:txBody>
-      </p:sp>
-      <p:sp>
-        <p:nvSpPr>
-          <p:cNvPr id="19" name="Text 17">
-            <a:extLst>
-              <a:ext uri="{FF2B5EF4-FFF2-40B4-BE49-F238E27FC236}">
-                <a16:creationId xmlns:a16="http://schemas.microsoft.com/office/drawing/2014/main" id="{82F49AF6-9A5A-93C7-B5CB-2400820B899C}"/>
-              </a:ext>
-            </a:extLst>
-          </p:cNvPr>
-          <p:cNvSpPr/>
-          <p:nvPr/>
-        </p:nvSpPr>
-        <p:spPr>
-          <a:xfrm>
-            <a:off x="731520" y="4617720"/>
-            <a:ext cx="7680960" cy="365760"/>
-          </a:xfrm>
-          <a:prstGeom prst="rect">
-            <a:avLst/>
-          </a:prstGeom>
-          <a:noFill/>
-          <a:ln/>
-        </p:spPr>
-        <p:txBody>
-          <a:bodyPr wrap="square" rtlCol="0" anchor="ctr"/>
-          <a:lstStyle/>
-          <a:p>
-            <a:pPr marL="0" indent="0" algn="ctr">
-              <a:buNone/>
-            </a:pPr>
-            <a:r>
-              <a:rPr lang="en-US" sz="1100" dirty="0">
-                <a:solidFill>
-                  <a:srgbClr val="556688"/>
-                </a:solidFill>
-                <a:latin typeface="Calibri" pitchFamily="34" charset="0"/>
-                <a:ea typeface="Calibri" pitchFamily="34" charset="-122"/>
-                <a:cs typeface="Calibri" pitchFamily="34" charset="-120"/>
-              </a:rPr>
-              <a:t>Ben Heim &amp; Adam Tuchler  |  University of Chicago</a:t>
-            </a:r>
-            <a:endParaRPr lang="en-US" sz="1100" dirty="0"/>
-          </a:p>
-        </p:txBody>
-      </p:sp>
-    </p:spTree>
-    <p:extLst>
-      <p:ext uri="{BB962C8B-B14F-4D97-AF65-F5344CB8AC3E}">
-        <p14:creationId xmlns:p14="http://schemas.microsoft.com/office/powerpoint/2010/main" val="1971334516"/>
-      </p:ext>
-    </p:extLst>
-  </p:cSld>
-  <p:clrMapOvr>
-    <a:masterClrMapping/>
-  </p:clrMapOvr>
-</p:sld>
-</file>
-
-<file path=ppt/slides/slide19.xml><?xml version="1.0" encoding="utf-8"?>
-<p:sld xmlns:a="http://schemas.openxmlformats.org/drawingml/2006/main" xmlns:r="http://schemas.openxmlformats.org/officeDocument/2006/relationships" xmlns:p="http://schemas.openxmlformats.org/presentationml/2006/main">
-  <p:cSld>
-    <p:spTree>
-      <p:nvGrpSpPr>
-        <p:cNvPr id="1" name=""/>
-        <p:cNvGrpSpPr/>
-        <p:nvPr/>
-      </p:nvGrpSpPr>
-      <p:grpSpPr>
-        <a:xfrm>
-          <a:off x="0" y="0"/>
-          <a:ext cx="0" cy="0"/>
-          <a:chOff x="0" y="0"/>
-          <a:chExt cx="0" cy="0"/>
-        </a:xfrm>
-      </p:grpSpPr>
-      <p:sp>
-        <p:nvSpPr>
-          <p:cNvPr id="2" name="TextBox 1"/>
-          <p:cNvSpPr txBox="1"/>
-          <p:nvPr/>
-        </p:nvSpPr>
-        <p:spPr>
-          <a:xfrm>
-            <a:off x="548640" y="274320"/>
-            <a:ext cx="8046720" cy="548640"/>
-          </a:xfrm>
-          <a:prstGeom prst="rect">
-            <a:avLst/>
-          </a:prstGeom>
-          <a:noFill/>
-        </p:spPr>
-        <p:txBody>
-          <a:bodyPr wrap="square" anchor="t">
-            <a:spAutoFit/>
-          </a:bodyPr>
-          <a:lstStyle/>
-          <a:p>
-            <a:pPr algn="l">
-              <a:defRPr sz="2800" b="1" i="0">
-                <a:solidFill>
-                  <a:srgbClr val="1E2761"/>
-                </a:solidFill>
-                <a:latin typeface="Georgia"/>
-              </a:defRPr>
-            </a:pPr>
-            <a:r>
-              <a:t>Future Work</a:t>
-            </a:r>
-          </a:p>
-        </p:txBody>
-      </p:sp>
-      <p:sp>
-        <p:nvSpPr>
-          <p:cNvPr id="3" name="Oval 2"/>
-          <p:cNvSpPr/>
-          <p:nvPr/>
-        </p:nvSpPr>
-        <p:spPr>
-          <a:xfrm>
-            <a:off x="548640" y="1097280"/>
-            <a:ext cx="411480" cy="411480"/>
-          </a:xfrm>
-          <a:prstGeom prst="ellipse">
-            <a:avLst/>
-          </a:prstGeom>
-          <a:solidFill>
-            <a:srgbClr val="3A7BD5"/>
-          </a:solidFill>
-          <a:ln>
-            <a:noFill/>
-          </a:ln>
-        </p:spPr>
-        <p:style>
-          <a:lnRef idx="1">
-            <a:schemeClr val="accent1"/>
-          </a:lnRef>
-          <a:fillRef idx="3">
-            <a:schemeClr val="accent1"/>
-          </a:fillRef>
-          <a:effectRef idx="2">
-            <a:schemeClr val="accent1"/>
-          </a:effectRef>
-          <a:fontRef idx="minor">
-            <a:schemeClr val="lt1"/>
-          </a:fontRef>
-        </p:style>
-        <p:txBody>
-          <a:bodyPr wrap="none" rtlCol="0" anchor="ctr"/>
-          <a:lstStyle/>
-          <a:p>
-            <a:pPr algn="ctr">
-              <a:defRPr sz="1600" b="1">
-                <a:solidFill>
-                  <a:srgbClr val="FFFFFF"/>
-                </a:solidFill>
-                <a:latin typeface="Calibri"/>
-              </a:defRPr>
-            </a:pPr>
-            <a:r>
-              <a:t>1</a:t>
-            </a:r>
-          </a:p>
-        </p:txBody>
-      </p:sp>
-      <p:sp>
-        <p:nvSpPr>
-          <p:cNvPr id="4" name="TextBox 3"/>
-          <p:cNvSpPr txBox="1"/>
-          <p:nvPr/>
-        </p:nvSpPr>
-        <p:spPr>
-          <a:xfrm>
-            <a:off x="1188720" y="1097280"/>
-            <a:ext cx="7406640" cy="320040"/>
-          </a:xfrm>
-          <a:prstGeom prst="rect">
-            <a:avLst/>
-          </a:prstGeom>
-          <a:noFill/>
-        </p:spPr>
-        <p:txBody>
-          <a:bodyPr wrap="square" anchor="t">
-            <a:spAutoFit/>
-          </a:bodyPr>
-          <a:lstStyle/>
-          <a:p>
-            <a:pPr algn="l">
-              <a:defRPr sz="1600" b="1" i="0">
-                <a:solidFill>
-                  <a:srgbClr val="1E2761"/>
-                </a:solidFill>
-                <a:latin typeface="Calibri"/>
-              </a:defRPr>
-            </a:pPr>
-            <a:r>
-              <a:t>Do cross-disciplinary citations produce lasting impact?</a:t>
-            </a:r>
-          </a:p>
-        </p:txBody>
-      </p:sp>
-      <p:sp>
-        <p:nvSpPr>
-          <p:cNvPr id="5" name="TextBox 4"/>
-          <p:cNvSpPr txBox="1"/>
-          <p:nvPr/>
-        </p:nvSpPr>
-        <p:spPr>
-          <a:xfrm>
-            <a:off x="1188720" y="1444752"/>
-            <a:ext cx="7406640" cy="731520"/>
-          </a:xfrm>
-          <a:prstGeom prst="rect">
-            <a:avLst/>
-          </a:prstGeom>
-          <a:noFill/>
-        </p:spPr>
-        <p:txBody>
-          <a:bodyPr wrap="square" anchor="t">
-            <a:spAutoFit/>
-          </a:bodyPr>
-          <a:lstStyle/>
-          <a:p>
-            <a:pPr algn="l">
-              <a:defRPr sz="1200" b="0" i="0">
-                <a:solidFill>
-                  <a:srgbClr val="1E2761"/>
-                </a:solidFill>
-                <a:latin typeface="Calibri"/>
-              </a:defRPr>
-            </a:pPr>
-            <a:r>
-              <a:t>Track forward citations, disruption indices (CD₅), and knowledge persistence of AI-era papers over 3–5 years. Tests whether the entropy increase we document translates into genuine knowledge integration or superficial breadth — directly engaging Hao et al.’s knowledge contraction and Kusumegi et al.’s quality decline findings.</a:t>
-            </a:r>
-          </a:p>
-        </p:txBody>
-      </p:sp>
-      <p:sp>
-        <p:nvSpPr>
-          <p:cNvPr id="9" name="Oval 8"/>
-          <p:cNvSpPr/>
-          <p:nvPr/>
-        </p:nvSpPr>
-        <p:spPr>
-          <a:xfrm>
-            <a:off x="548640" y="2673192"/>
-            <a:ext cx="411480" cy="411480"/>
-          </a:xfrm>
-          <a:prstGeom prst="ellipse">
-            <a:avLst/>
-          </a:prstGeom>
-          <a:solidFill>
-            <a:srgbClr val="3A7BD5"/>
-          </a:solidFill>
-          <a:ln>
-            <a:noFill/>
-          </a:ln>
-        </p:spPr>
-        <p:style>
-          <a:lnRef idx="1">
-            <a:schemeClr val="accent1"/>
-          </a:lnRef>
-          <a:fillRef idx="3">
-            <a:schemeClr val="accent1"/>
-          </a:fillRef>
-          <a:effectRef idx="2">
-            <a:schemeClr val="accent1"/>
-          </a:effectRef>
-          <a:fontRef idx="minor">
-            <a:schemeClr val="lt1"/>
-          </a:fontRef>
-        </p:style>
-        <p:txBody>
-          <a:bodyPr wrap="none" rtlCol="0" anchor="ctr"/>
-          <a:lstStyle/>
-          <a:p>
-            <a:pPr algn="ctr">
-              <a:defRPr sz="1600" b="1">
-                <a:solidFill>
-                  <a:srgbClr val="FFFFFF"/>
-                </a:solidFill>
-                <a:latin typeface="Calibri"/>
-              </a:defRPr>
-            </a:pPr>
-            <a:r>
-              <a:rPr lang="en-US" dirty="0"/>
-              <a:t>2</a:t>
-            </a:r>
-            <a:endParaRPr dirty="0"/>
-          </a:p>
-        </p:txBody>
-      </p:sp>
-      <p:sp>
-        <p:nvSpPr>
-          <p:cNvPr id="10" name="TextBox 9"/>
-          <p:cNvSpPr txBox="1"/>
-          <p:nvPr/>
-        </p:nvSpPr>
-        <p:spPr>
-          <a:xfrm>
-            <a:off x="1188720" y="2647189"/>
-            <a:ext cx="7406640" cy="320040"/>
-          </a:xfrm>
-          <a:prstGeom prst="rect">
-            <a:avLst/>
-          </a:prstGeom>
-          <a:noFill/>
-        </p:spPr>
-        <p:txBody>
-          <a:bodyPr wrap="square" anchor="t">
-            <a:spAutoFit/>
-          </a:bodyPr>
-          <a:lstStyle/>
-          <a:p>
-            <a:pPr algn="l">
-              <a:defRPr sz="1600" b="1" i="0">
-                <a:solidFill>
-                  <a:srgbClr val="1E2761"/>
-                </a:solidFill>
-                <a:latin typeface="Calibri"/>
-              </a:defRPr>
-            </a:pPr>
-            <a:r>
-              <a:t>Disentangle the mechanism</a:t>
-            </a:r>
-          </a:p>
-        </p:txBody>
-      </p:sp>
-      <p:sp>
-        <p:nvSpPr>
-          <p:cNvPr id="11" name="TextBox 10"/>
-          <p:cNvSpPr txBox="1"/>
-          <p:nvPr/>
-        </p:nvSpPr>
-        <p:spPr>
-          <a:xfrm>
-            <a:off x="1188720" y="2994661"/>
-            <a:ext cx="7406640" cy="594360"/>
-          </a:xfrm>
-          <a:prstGeom prst="rect">
-            <a:avLst/>
-          </a:prstGeom>
-          <a:noFill/>
-        </p:spPr>
-        <p:txBody>
-          <a:bodyPr wrap="square" anchor="t">
-            <a:spAutoFit/>
-          </a:bodyPr>
-          <a:lstStyle/>
-          <a:p>
-            <a:pPr algn="l">
-              <a:defRPr sz="1200" b="0" i="0">
-                <a:solidFill>
-                  <a:srgbClr val="1E2761"/>
-                </a:solidFill>
-                <a:latin typeface="Calibri"/>
-              </a:defRPr>
-            </a:pPr>
-            <a:r>
-              <a:rPr dirty="0"/>
-              <a:t>Are researchers discovering new literatures through LLM suggestions (</a:t>
-            </a:r>
-            <a:r>
-              <a:rPr dirty="0" err="1"/>
-              <a:t>Algaba’s</a:t>
-            </a:r>
-            <a:r>
-              <a:rPr dirty="0"/>
-              <a:t> channel), or does LLM-assisted writing lower the cost of integrating sources they already knew about? Experimental or survey-based designs could separate these pathways.</a:t>
-            </a:r>
-          </a:p>
-        </p:txBody>
-      </p:sp>
-    </p:spTree>
   </p:cSld>
   <p:clrMapOvr>
     <a:masterClrMapping/>
@@ -9111,15 +9391,6 @@
             <a:endParaRPr lang="en-US" sz="1800" dirty="0"/>
           </a:p>
           <a:p>
-            <a:pPr marL="0" indent="0">
-              <a:spcAft>
-                <a:spcPts val="600"/>
-              </a:spcAft>
-              <a:buNone/>
-            </a:pPr>
-            <a:endParaRPr lang="en-US" sz="1800" dirty="0"/>
-          </a:p>
-          <a:p>
             <a:pPr marL="342900" indent="-342900">
               <a:spcAft>
                 <a:spcPts val="600"/>
@@ -9249,6 +9520,1506 @@
         </p:txBody>
       </p:sp>
     </p:spTree>
+  </p:cSld>
+  <p:clrMapOvr>
+    <a:masterClrMapping/>
+  </p:clrMapOvr>
+</p:sld>
+</file>
+
+<file path=ppt/slides/slide20.xml><?xml version="1.0" encoding="utf-8"?>
+<p:sld xmlns:a="http://schemas.openxmlformats.org/drawingml/2006/main" xmlns:r="http://schemas.openxmlformats.org/officeDocument/2006/relationships" xmlns:p="http://schemas.openxmlformats.org/presentationml/2006/main">
+  <p:cSld>
+    <p:bg>
+      <p:bgPr>
+        <a:solidFill>
+          <a:srgbClr val="1E2761"/>
+        </a:solidFill>
+        <a:effectLst/>
+      </p:bgPr>
+    </p:bg>
+    <p:spTree>
+      <p:nvGrpSpPr>
+        <p:cNvPr id="1" name="">
+          <a:extLst>
+            <a:ext uri="{FF2B5EF4-FFF2-40B4-BE49-F238E27FC236}">
+              <a16:creationId xmlns:a16="http://schemas.microsoft.com/office/drawing/2014/main" id="{017323DF-F73E-73C8-ED03-ADE3BBAE66EB}"/>
+            </a:ext>
+          </a:extLst>
+        </p:cNvPr>
+        <p:cNvGrpSpPr/>
+        <p:nvPr/>
+      </p:nvGrpSpPr>
+      <p:grpSpPr>
+        <a:xfrm>
+          <a:off x="0" y="0"/>
+          <a:ext cx="0" cy="0"/>
+          <a:chOff x="0" y="0"/>
+          <a:chExt cx="0" cy="0"/>
+        </a:xfrm>
+      </p:grpSpPr>
+      <p:sp>
+        <p:nvSpPr>
+          <p:cNvPr id="2" name="Text 0">
+            <a:extLst>
+              <a:ext uri="{FF2B5EF4-FFF2-40B4-BE49-F238E27FC236}">
+                <a16:creationId xmlns:a16="http://schemas.microsoft.com/office/drawing/2014/main" id="{9B3884E1-EA25-66BB-D7E8-702E2351DEE9}"/>
+              </a:ext>
+            </a:extLst>
+          </p:cNvPr>
+          <p:cNvSpPr/>
+          <p:nvPr/>
+        </p:nvSpPr>
+        <p:spPr>
+          <a:xfrm>
+            <a:off x="731520" y="365760"/>
+            <a:ext cx="7680960" cy="640080"/>
+          </a:xfrm>
+          <a:prstGeom prst="rect">
+            <a:avLst/>
+          </a:prstGeom>
+          <a:noFill/>
+          <a:ln/>
+        </p:spPr>
+        <p:txBody>
+          <a:bodyPr wrap="square" lIns="0" tIns="0" rIns="0" bIns="0" rtlCol="0" anchor="ctr"/>
+          <a:lstStyle/>
+          <a:p>
+            <a:pPr marL="0" indent="0">
+              <a:buNone/>
+            </a:pPr>
+            <a:r>
+              <a:rPr lang="en-US" sz="3200" b="1" dirty="0">
+                <a:solidFill>
+                  <a:srgbClr val="FFFFFF"/>
+                </a:solidFill>
+                <a:latin typeface="Georgia" pitchFamily="34" charset="0"/>
+                <a:ea typeface="Georgia" pitchFamily="34" charset="-122"/>
+                <a:cs typeface="Georgia" pitchFamily="34" charset="-120"/>
+              </a:rPr>
+              <a:t>Key Takeaways</a:t>
+            </a:r>
+            <a:endParaRPr lang="en-US" sz="3200" dirty="0"/>
+          </a:p>
+        </p:txBody>
+      </p:sp>
+      <p:sp>
+        <p:nvSpPr>
+          <p:cNvPr id="3" name="Shape 1">
+            <a:extLst>
+              <a:ext uri="{FF2B5EF4-FFF2-40B4-BE49-F238E27FC236}">
+                <a16:creationId xmlns:a16="http://schemas.microsoft.com/office/drawing/2014/main" id="{781AC0B1-C8DB-8133-B709-786CE84206A3}"/>
+              </a:ext>
+            </a:extLst>
+          </p:cNvPr>
+          <p:cNvSpPr/>
+          <p:nvPr/>
+        </p:nvSpPr>
+        <p:spPr>
+          <a:xfrm>
+            <a:off x="731520" y="1280160"/>
+            <a:ext cx="411480" cy="411480"/>
+          </a:xfrm>
+          <a:prstGeom prst="ellipse">
+            <a:avLst/>
+          </a:prstGeom>
+          <a:solidFill>
+            <a:srgbClr val="3A7BD5"/>
+          </a:solidFill>
+          <a:ln/>
+        </p:spPr>
+        <p:txBody>
+          <a:bodyPr/>
+          <a:lstStyle/>
+          <a:p>
+            <a:endParaRPr lang="en-US"/>
+          </a:p>
+        </p:txBody>
+      </p:sp>
+      <p:sp>
+        <p:nvSpPr>
+          <p:cNvPr id="4" name="Text 2">
+            <a:extLst>
+              <a:ext uri="{FF2B5EF4-FFF2-40B4-BE49-F238E27FC236}">
+                <a16:creationId xmlns:a16="http://schemas.microsoft.com/office/drawing/2014/main" id="{ACAE4663-2783-282D-5B4C-1964528CD493}"/>
+              </a:ext>
+            </a:extLst>
+          </p:cNvPr>
+          <p:cNvSpPr/>
+          <p:nvPr/>
+        </p:nvSpPr>
+        <p:spPr>
+          <a:xfrm>
+            <a:off x="731520" y="1280160"/>
+            <a:ext cx="411480" cy="411480"/>
+          </a:xfrm>
+          <a:prstGeom prst="rect">
+            <a:avLst/>
+          </a:prstGeom>
+          <a:noFill/>
+          <a:ln/>
+        </p:spPr>
+        <p:txBody>
+          <a:bodyPr wrap="square" rtlCol="0" anchor="ctr"/>
+          <a:lstStyle/>
+          <a:p>
+            <a:pPr marL="0" indent="0" algn="ctr">
+              <a:buNone/>
+            </a:pPr>
+            <a:r>
+              <a:rPr lang="en-US" sz="1600" b="1" dirty="0">
+                <a:solidFill>
+                  <a:srgbClr val="FFFFFF"/>
+                </a:solidFill>
+                <a:latin typeface="Calibri" pitchFamily="34" charset="0"/>
+                <a:ea typeface="Calibri" pitchFamily="34" charset="-122"/>
+                <a:cs typeface="Calibri" pitchFamily="34" charset="-120"/>
+              </a:rPr>
+              <a:t>1</a:t>
+            </a:r>
+            <a:endParaRPr lang="en-US" sz="1600" dirty="0"/>
+          </a:p>
+        </p:txBody>
+      </p:sp>
+      <p:sp>
+        <p:nvSpPr>
+          <p:cNvPr id="5" name="Text 3">
+            <a:extLst>
+              <a:ext uri="{FF2B5EF4-FFF2-40B4-BE49-F238E27FC236}">
+                <a16:creationId xmlns:a16="http://schemas.microsoft.com/office/drawing/2014/main" id="{03F29060-F554-DF50-3B22-DA5ADA16DF29}"/>
+              </a:ext>
+            </a:extLst>
+          </p:cNvPr>
+          <p:cNvSpPr/>
+          <p:nvPr/>
+        </p:nvSpPr>
+        <p:spPr>
+          <a:xfrm>
+            <a:off x="1371600" y="1234440"/>
+            <a:ext cx="7040880" cy="320040"/>
+          </a:xfrm>
+          <a:prstGeom prst="rect">
+            <a:avLst/>
+          </a:prstGeom>
+          <a:noFill/>
+          <a:ln/>
+        </p:spPr>
+        <p:txBody>
+          <a:bodyPr wrap="square" lIns="0" tIns="0" rIns="0" bIns="0" rtlCol="0" anchor="ctr"/>
+          <a:lstStyle/>
+          <a:p>
+            <a:pPr marL="0" indent="0">
+              <a:buNone/>
+            </a:pPr>
+            <a:r>
+              <a:rPr lang="en-US" sz="1600" b="1" dirty="0">
+                <a:solidFill>
+                  <a:srgbClr val="FFFFFF"/>
+                </a:solidFill>
+                <a:latin typeface="Calibri" pitchFamily="34" charset="0"/>
+                <a:ea typeface="Calibri" pitchFamily="34" charset="-122"/>
+                <a:cs typeface="Calibri" pitchFamily="34" charset="-120"/>
+              </a:rPr>
+              <a:t>LLM Adoption Causes an Increase in Citation Diversity </a:t>
+            </a:r>
+            <a:endParaRPr lang="en-US" sz="1600" dirty="0"/>
+          </a:p>
+        </p:txBody>
+      </p:sp>
+      <p:sp>
+        <p:nvSpPr>
+          <p:cNvPr id="6" name="Text 4">
+            <a:extLst>
+              <a:ext uri="{FF2B5EF4-FFF2-40B4-BE49-F238E27FC236}">
+                <a16:creationId xmlns:a16="http://schemas.microsoft.com/office/drawing/2014/main" id="{F7B80644-6101-89A2-DA26-4D5B01023908}"/>
+              </a:ext>
+            </a:extLst>
+          </p:cNvPr>
+          <p:cNvSpPr/>
+          <p:nvPr/>
+        </p:nvSpPr>
+        <p:spPr>
+          <a:xfrm>
+            <a:off x="1371600" y="1554480"/>
+            <a:ext cx="7040880" cy="411480"/>
+          </a:xfrm>
+          <a:prstGeom prst="rect">
+            <a:avLst/>
+          </a:prstGeom>
+          <a:noFill/>
+          <a:ln/>
+        </p:spPr>
+        <p:txBody>
+          <a:bodyPr wrap="square" lIns="0" tIns="0" rIns="0" bIns="0" rtlCol="0" anchor="ctr"/>
+          <a:lstStyle/>
+          <a:p>
+            <a:pPr marL="0" indent="0">
+              <a:buNone/>
+            </a:pPr>
+            <a:r>
+              <a:rPr lang="en-US" sz="1200" dirty="0">
+                <a:solidFill>
+                  <a:srgbClr val="CADCFC"/>
+                </a:solidFill>
+                <a:latin typeface="Calibri" pitchFamily="34" charset="0"/>
+                <a:ea typeface="Calibri" pitchFamily="34" charset="-122"/>
+                <a:cs typeface="Calibri" pitchFamily="34" charset="-120"/>
+              </a:rPr>
+              <a:t>Shannon entropy increases by +0.031 nats/month in high-propensity fields post-4o. This is a robust finding.</a:t>
+            </a:r>
+            <a:endParaRPr lang="en-US" sz="1200" dirty="0"/>
+          </a:p>
+        </p:txBody>
+      </p:sp>
+      <p:sp>
+        <p:nvSpPr>
+          <p:cNvPr id="7" name="Shape 5">
+            <a:extLst>
+              <a:ext uri="{FF2B5EF4-FFF2-40B4-BE49-F238E27FC236}">
+                <a16:creationId xmlns:a16="http://schemas.microsoft.com/office/drawing/2014/main" id="{8A239DFF-2A49-53C8-6450-89495E6D1576}"/>
+              </a:ext>
+            </a:extLst>
+          </p:cNvPr>
+          <p:cNvSpPr/>
+          <p:nvPr/>
+        </p:nvSpPr>
+        <p:spPr>
+          <a:xfrm>
+            <a:off x="731520" y="2194560"/>
+            <a:ext cx="411480" cy="411480"/>
+          </a:xfrm>
+          <a:prstGeom prst="ellipse">
+            <a:avLst/>
+          </a:prstGeom>
+          <a:solidFill>
+            <a:srgbClr val="3A7BD5"/>
+          </a:solidFill>
+          <a:ln/>
+        </p:spPr>
+        <p:txBody>
+          <a:bodyPr/>
+          <a:lstStyle/>
+          <a:p>
+            <a:endParaRPr lang="en-US"/>
+          </a:p>
+        </p:txBody>
+      </p:sp>
+      <p:sp>
+        <p:nvSpPr>
+          <p:cNvPr id="8" name="Text 6">
+            <a:extLst>
+              <a:ext uri="{FF2B5EF4-FFF2-40B4-BE49-F238E27FC236}">
+                <a16:creationId xmlns:a16="http://schemas.microsoft.com/office/drawing/2014/main" id="{BFB364C2-7EE0-8596-F287-696052348DA3}"/>
+              </a:ext>
+            </a:extLst>
+          </p:cNvPr>
+          <p:cNvSpPr/>
+          <p:nvPr/>
+        </p:nvSpPr>
+        <p:spPr>
+          <a:xfrm>
+            <a:off x="731520" y="2194560"/>
+            <a:ext cx="411480" cy="411480"/>
+          </a:xfrm>
+          <a:prstGeom prst="rect">
+            <a:avLst/>
+          </a:prstGeom>
+          <a:noFill/>
+          <a:ln/>
+        </p:spPr>
+        <p:txBody>
+          <a:bodyPr wrap="square" rtlCol="0" anchor="ctr"/>
+          <a:lstStyle/>
+          <a:p>
+            <a:pPr marL="0" indent="0" algn="ctr">
+              <a:buNone/>
+            </a:pPr>
+            <a:r>
+              <a:rPr lang="en-US" sz="1600" b="1" dirty="0">
+                <a:solidFill>
+                  <a:srgbClr val="FFFFFF"/>
+                </a:solidFill>
+                <a:latin typeface="Calibri" pitchFamily="34" charset="0"/>
+                <a:ea typeface="Calibri" pitchFamily="34" charset="-122"/>
+                <a:cs typeface="Calibri" pitchFamily="34" charset="-120"/>
+              </a:rPr>
+              <a:t>2</a:t>
+            </a:r>
+            <a:endParaRPr lang="en-US" sz="1600" dirty="0"/>
+          </a:p>
+        </p:txBody>
+      </p:sp>
+      <p:sp>
+        <p:nvSpPr>
+          <p:cNvPr id="9" name="Text 7">
+            <a:extLst>
+              <a:ext uri="{FF2B5EF4-FFF2-40B4-BE49-F238E27FC236}">
+                <a16:creationId xmlns:a16="http://schemas.microsoft.com/office/drawing/2014/main" id="{E8ACE3D1-402E-0BE3-422D-5D8E4907CDA5}"/>
+              </a:ext>
+            </a:extLst>
+          </p:cNvPr>
+          <p:cNvSpPr/>
+          <p:nvPr/>
+        </p:nvSpPr>
+        <p:spPr>
+          <a:xfrm>
+            <a:off x="1371600" y="2148840"/>
+            <a:ext cx="7040880" cy="320040"/>
+          </a:xfrm>
+          <a:prstGeom prst="rect">
+            <a:avLst/>
+          </a:prstGeom>
+          <a:noFill/>
+          <a:ln/>
+        </p:spPr>
+        <p:txBody>
+          <a:bodyPr wrap="square" lIns="0" tIns="0" rIns="0" bIns="0" rtlCol="0" anchor="ctr"/>
+          <a:lstStyle/>
+          <a:p>
+            <a:pPr marL="0" indent="0">
+              <a:buNone/>
+            </a:pPr>
+            <a:r>
+              <a:rPr lang="en-US" sz="1600" b="1" dirty="0">
+                <a:solidFill>
+                  <a:srgbClr val="FFFFFF"/>
+                </a:solidFill>
+                <a:latin typeface="Calibri" pitchFamily="34" charset="0"/>
+                <a:ea typeface="Calibri" pitchFamily="34" charset="-122"/>
+                <a:cs typeface="Calibri" pitchFamily="34" charset="-120"/>
+              </a:rPr>
+              <a:t>Effect is gradual, not a jump</a:t>
+            </a:r>
+            <a:endParaRPr lang="en-US" sz="1600" dirty="0"/>
+          </a:p>
+        </p:txBody>
+      </p:sp>
+      <p:sp>
+        <p:nvSpPr>
+          <p:cNvPr id="10" name="Text 8">
+            <a:extLst>
+              <a:ext uri="{FF2B5EF4-FFF2-40B4-BE49-F238E27FC236}">
+                <a16:creationId xmlns:a16="http://schemas.microsoft.com/office/drawing/2014/main" id="{A20BEF4E-FCC6-DBDD-8701-93F0D586F723}"/>
+              </a:ext>
+            </a:extLst>
+          </p:cNvPr>
+          <p:cNvSpPr/>
+          <p:nvPr/>
+        </p:nvSpPr>
+        <p:spPr>
+          <a:xfrm>
+            <a:off x="1371600" y="2468880"/>
+            <a:ext cx="7040880" cy="411480"/>
+          </a:xfrm>
+          <a:prstGeom prst="rect">
+            <a:avLst/>
+          </a:prstGeom>
+          <a:noFill/>
+          <a:ln/>
+        </p:spPr>
+        <p:txBody>
+          <a:bodyPr wrap="square" lIns="0" tIns="0" rIns="0" bIns="0" rtlCol="0" anchor="ctr"/>
+          <a:lstStyle/>
+          <a:p>
+            <a:pPr marL="0" indent="0">
+              <a:buNone/>
+            </a:pPr>
+            <a:r>
+              <a:rPr lang="en-US" sz="1200" dirty="0">
+                <a:solidFill>
+                  <a:srgbClr val="CADCFC"/>
+                </a:solidFill>
+                <a:latin typeface="Calibri" pitchFamily="34" charset="0"/>
+                <a:ea typeface="Calibri" pitchFamily="34" charset="-122"/>
+                <a:cs typeface="Calibri" pitchFamily="34" charset="-120"/>
+              </a:rPr>
+              <a:t>Treatment × trend specification fits better than level shift — consistent with diffusion</a:t>
+            </a:r>
+            <a:endParaRPr lang="en-US" sz="1200" dirty="0"/>
+          </a:p>
+        </p:txBody>
+      </p:sp>
+      <p:sp>
+        <p:nvSpPr>
+          <p:cNvPr id="11" name="Shape 9">
+            <a:extLst>
+              <a:ext uri="{FF2B5EF4-FFF2-40B4-BE49-F238E27FC236}">
+                <a16:creationId xmlns:a16="http://schemas.microsoft.com/office/drawing/2014/main" id="{E04492E1-BF96-E02C-461D-68ECEF96F55A}"/>
+              </a:ext>
+            </a:extLst>
+          </p:cNvPr>
+          <p:cNvSpPr/>
+          <p:nvPr/>
+        </p:nvSpPr>
+        <p:spPr>
+          <a:xfrm>
+            <a:off x="731520" y="3108960"/>
+            <a:ext cx="411480" cy="411480"/>
+          </a:xfrm>
+          <a:prstGeom prst="ellipse">
+            <a:avLst/>
+          </a:prstGeom>
+          <a:solidFill>
+            <a:srgbClr val="3A7BD5"/>
+          </a:solidFill>
+          <a:ln/>
+        </p:spPr>
+        <p:txBody>
+          <a:bodyPr/>
+          <a:lstStyle/>
+          <a:p>
+            <a:endParaRPr lang="en-US"/>
+          </a:p>
+        </p:txBody>
+      </p:sp>
+      <p:sp>
+        <p:nvSpPr>
+          <p:cNvPr id="12" name="Text 10">
+            <a:extLst>
+              <a:ext uri="{FF2B5EF4-FFF2-40B4-BE49-F238E27FC236}">
+                <a16:creationId xmlns:a16="http://schemas.microsoft.com/office/drawing/2014/main" id="{6EA824BD-9369-0B4B-7819-14AFEC9D69B4}"/>
+              </a:ext>
+            </a:extLst>
+          </p:cNvPr>
+          <p:cNvSpPr/>
+          <p:nvPr/>
+        </p:nvSpPr>
+        <p:spPr>
+          <a:xfrm>
+            <a:off x="731520" y="3108960"/>
+            <a:ext cx="411480" cy="411480"/>
+          </a:xfrm>
+          <a:prstGeom prst="rect">
+            <a:avLst/>
+          </a:prstGeom>
+          <a:noFill/>
+          <a:ln/>
+        </p:spPr>
+        <p:txBody>
+          <a:bodyPr wrap="square" rtlCol="0" anchor="ctr"/>
+          <a:lstStyle/>
+          <a:p>
+            <a:pPr marL="0" indent="0" algn="ctr">
+              <a:buNone/>
+            </a:pPr>
+            <a:r>
+              <a:rPr lang="en-US" sz="1600" b="1" dirty="0">
+                <a:solidFill>
+                  <a:srgbClr val="FFFFFF"/>
+                </a:solidFill>
+                <a:latin typeface="Calibri" pitchFamily="34" charset="0"/>
+                <a:ea typeface="Calibri" pitchFamily="34" charset="-122"/>
+                <a:cs typeface="Calibri" pitchFamily="34" charset="-120"/>
+              </a:rPr>
+              <a:t>3</a:t>
+            </a:r>
+            <a:endParaRPr lang="en-US" sz="1600" dirty="0"/>
+          </a:p>
+        </p:txBody>
+      </p:sp>
+      <p:sp>
+        <p:nvSpPr>
+          <p:cNvPr id="13" name="Text 11">
+            <a:extLst>
+              <a:ext uri="{FF2B5EF4-FFF2-40B4-BE49-F238E27FC236}">
+                <a16:creationId xmlns:a16="http://schemas.microsoft.com/office/drawing/2014/main" id="{6C645505-5D25-92E7-5830-40E37DEF4ED8}"/>
+              </a:ext>
+            </a:extLst>
+          </p:cNvPr>
+          <p:cNvSpPr/>
+          <p:nvPr/>
+        </p:nvSpPr>
+        <p:spPr>
+          <a:xfrm>
+            <a:off x="1371600" y="3063240"/>
+            <a:ext cx="7040880" cy="320040"/>
+          </a:xfrm>
+          <a:prstGeom prst="rect">
+            <a:avLst/>
+          </a:prstGeom>
+          <a:noFill/>
+          <a:ln/>
+        </p:spPr>
+        <p:txBody>
+          <a:bodyPr wrap="square" lIns="0" tIns="0" rIns="0" bIns="0" rtlCol="0" anchor="ctr"/>
+          <a:lstStyle/>
+          <a:p>
+            <a:pPr marL="0" indent="0">
+              <a:buNone/>
+            </a:pPr>
+            <a:r>
+              <a:rPr lang="en-US" sz="1600" b="1" dirty="0">
+                <a:solidFill>
+                  <a:srgbClr val="FFFFFF"/>
+                </a:solidFill>
+                <a:latin typeface="Calibri" pitchFamily="34" charset="0"/>
+                <a:ea typeface="Calibri" pitchFamily="34" charset="-122"/>
+                <a:cs typeface="Calibri" pitchFamily="34" charset="-120"/>
+              </a:rPr>
+              <a:t>Consistent across measures</a:t>
+            </a:r>
+            <a:endParaRPr lang="en-US" sz="1600" dirty="0"/>
+          </a:p>
+        </p:txBody>
+      </p:sp>
+      <p:sp>
+        <p:nvSpPr>
+          <p:cNvPr id="14" name="Text 12">
+            <a:extLst>
+              <a:ext uri="{FF2B5EF4-FFF2-40B4-BE49-F238E27FC236}">
+                <a16:creationId xmlns:a16="http://schemas.microsoft.com/office/drawing/2014/main" id="{159C799E-0C6C-323C-4BB6-108BB1D33D51}"/>
+              </a:ext>
+            </a:extLst>
+          </p:cNvPr>
+          <p:cNvSpPr/>
+          <p:nvPr/>
+        </p:nvSpPr>
+        <p:spPr>
+          <a:xfrm>
+            <a:off x="1371600" y="3383280"/>
+            <a:ext cx="7040880" cy="411480"/>
+          </a:xfrm>
+          <a:prstGeom prst="rect">
+            <a:avLst/>
+          </a:prstGeom>
+          <a:noFill/>
+          <a:ln/>
+        </p:spPr>
+        <p:txBody>
+          <a:bodyPr wrap="square" lIns="0" tIns="0" rIns="0" bIns="0" rtlCol="0" anchor="ctr"/>
+          <a:lstStyle/>
+          <a:p>
+            <a:r>
+              <a:rPr lang="en-US" sz="1200" dirty="0">
+                <a:solidFill>
+                  <a:srgbClr val="CADCFC"/>
+                </a:solidFill>
+                <a:latin typeface="Calibri" pitchFamily="34" charset="0"/>
+                <a:ea typeface="Calibri" pitchFamily="34" charset="-122"/>
+                <a:cs typeface="Calibri" pitchFamily="34" charset="-120"/>
+              </a:rPr>
+              <a:t>Entropy, distinct fields cited, and within-field share all point the same direction</a:t>
+            </a:r>
+            <a:endParaRPr lang="en-US" sz="1200" dirty="0"/>
+          </a:p>
+        </p:txBody>
+      </p:sp>
+      <p:sp>
+        <p:nvSpPr>
+          <p:cNvPr id="15" name="Shape 13">
+            <a:extLst>
+              <a:ext uri="{FF2B5EF4-FFF2-40B4-BE49-F238E27FC236}">
+                <a16:creationId xmlns:a16="http://schemas.microsoft.com/office/drawing/2014/main" id="{36EC8B2C-78F2-849A-66EC-326F3396AB90}"/>
+              </a:ext>
+            </a:extLst>
+          </p:cNvPr>
+          <p:cNvSpPr/>
+          <p:nvPr/>
+        </p:nvSpPr>
+        <p:spPr>
+          <a:xfrm>
+            <a:off x="731520" y="4023360"/>
+            <a:ext cx="411480" cy="411480"/>
+          </a:xfrm>
+          <a:prstGeom prst="ellipse">
+            <a:avLst/>
+          </a:prstGeom>
+          <a:solidFill>
+            <a:srgbClr val="3A7BD5"/>
+          </a:solidFill>
+          <a:ln/>
+        </p:spPr>
+        <p:txBody>
+          <a:bodyPr/>
+          <a:lstStyle/>
+          <a:p>
+            <a:endParaRPr lang="en-US"/>
+          </a:p>
+        </p:txBody>
+      </p:sp>
+      <p:sp>
+        <p:nvSpPr>
+          <p:cNvPr id="16" name="Text 14">
+            <a:extLst>
+              <a:ext uri="{FF2B5EF4-FFF2-40B4-BE49-F238E27FC236}">
+                <a16:creationId xmlns:a16="http://schemas.microsoft.com/office/drawing/2014/main" id="{CE633D03-77B6-2594-460B-8271162B5034}"/>
+              </a:ext>
+            </a:extLst>
+          </p:cNvPr>
+          <p:cNvSpPr/>
+          <p:nvPr/>
+        </p:nvSpPr>
+        <p:spPr>
+          <a:xfrm>
+            <a:off x="731520" y="4023360"/>
+            <a:ext cx="411480" cy="411480"/>
+          </a:xfrm>
+          <a:prstGeom prst="rect">
+            <a:avLst/>
+          </a:prstGeom>
+          <a:noFill/>
+          <a:ln/>
+        </p:spPr>
+        <p:txBody>
+          <a:bodyPr wrap="square" rtlCol="0" anchor="ctr"/>
+          <a:lstStyle/>
+          <a:p>
+            <a:pPr marL="0" indent="0" algn="ctr">
+              <a:buNone/>
+            </a:pPr>
+            <a:r>
+              <a:rPr lang="en-US" sz="1600" b="1" dirty="0">
+                <a:solidFill>
+                  <a:srgbClr val="FFFFFF"/>
+                </a:solidFill>
+                <a:latin typeface="Calibri" pitchFamily="34" charset="0"/>
+                <a:ea typeface="Calibri" pitchFamily="34" charset="-122"/>
+                <a:cs typeface="Calibri" pitchFamily="34" charset="-120"/>
+              </a:rPr>
+              <a:t>4</a:t>
+            </a:r>
+            <a:endParaRPr lang="en-US" sz="1600" dirty="0"/>
+          </a:p>
+        </p:txBody>
+      </p:sp>
+      <p:sp>
+        <p:nvSpPr>
+          <p:cNvPr id="17" name="Text 15">
+            <a:extLst>
+              <a:ext uri="{FF2B5EF4-FFF2-40B4-BE49-F238E27FC236}">
+                <a16:creationId xmlns:a16="http://schemas.microsoft.com/office/drawing/2014/main" id="{67B7BFED-8797-AF2E-127E-2983B893AE2C}"/>
+              </a:ext>
+            </a:extLst>
+          </p:cNvPr>
+          <p:cNvSpPr/>
+          <p:nvPr/>
+        </p:nvSpPr>
+        <p:spPr>
+          <a:xfrm>
+            <a:off x="1371600" y="3977640"/>
+            <a:ext cx="7040880" cy="320040"/>
+          </a:xfrm>
+          <a:prstGeom prst="rect">
+            <a:avLst/>
+          </a:prstGeom>
+          <a:noFill/>
+          <a:ln/>
+        </p:spPr>
+        <p:txBody>
+          <a:bodyPr wrap="square" lIns="0" tIns="0" rIns="0" bIns="0" rtlCol="0" anchor="ctr"/>
+          <a:lstStyle/>
+          <a:p>
+            <a:pPr marL="0" indent="0">
+              <a:buNone/>
+            </a:pPr>
+            <a:r>
+              <a:rPr lang="en-US" sz="1600" b="1" dirty="0">
+                <a:solidFill>
+                  <a:srgbClr val="FFFFFF"/>
+                </a:solidFill>
+                <a:latin typeface="Calibri" pitchFamily="34" charset="0"/>
+                <a:ea typeface="Calibri" pitchFamily="34" charset="-122"/>
+                <a:cs typeface="Calibri" pitchFamily="34" charset="-120"/>
+              </a:rPr>
+              <a:t>Complements existing literature</a:t>
+            </a:r>
+            <a:endParaRPr lang="en-US" sz="1600" dirty="0"/>
+          </a:p>
+        </p:txBody>
+      </p:sp>
+      <p:sp>
+        <p:nvSpPr>
+          <p:cNvPr id="18" name="Text 16">
+            <a:extLst>
+              <a:ext uri="{FF2B5EF4-FFF2-40B4-BE49-F238E27FC236}">
+                <a16:creationId xmlns:a16="http://schemas.microsoft.com/office/drawing/2014/main" id="{BB156AA3-BE2D-7991-2643-1BFEC69EBF12}"/>
+              </a:ext>
+            </a:extLst>
+          </p:cNvPr>
+          <p:cNvSpPr/>
+          <p:nvPr/>
+        </p:nvSpPr>
+        <p:spPr>
+          <a:xfrm>
+            <a:off x="1371600" y="4297680"/>
+            <a:ext cx="7040880" cy="411480"/>
+          </a:xfrm>
+          <a:prstGeom prst="rect">
+            <a:avLst/>
+          </a:prstGeom>
+          <a:noFill/>
+          <a:ln/>
+        </p:spPr>
+        <p:txBody>
+          <a:bodyPr wrap="square" lIns="0" tIns="0" rIns="0" bIns="0" rtlCol="0" anchor="ctr"/>
+          <a:lstStyle/>
+          <a:p>
+            <a:pPr marL="0" indent="0">
+              <a:buNone/>
+            </a:pPr>
+            <a:r>
+              <a:rPr lang="en-US" sz="1200" dirty="0">
+                <a:solidFill>
+                  <a:srgbClr val="CADCFC"/>
+                </a:solidFill>
+                <a:latin typeface="Calibri" pitchFamily="34" charset="0"/>
+                <a:ea typeface="Calibri" pitchFamily="34" charset="-122"/>
+                <a:cs typeface="Calibri" pitchFamily="34" charset="-120"/>
+              </a:rPr>
+              <a:t>Hao et al. (2026) find AI contracts knowledge extent; we find it expands citation breadth — different margins</a:t>
+            </a:r>
+            <a:endParaRPr lang="en-US" sz="1200" dirty="0"/>
+          </a:p>
+        </p:txBody>
+      </p:sp>
+      <p:sp>
+        <p:nvSpPr>
+          <p:cNvPr id="19" name="Text 17">
+            <a:extLst>
+              <a:ext uri="{FF2B5EF4-FFF2-40B4-BE49-F238E27FC236}">
+                <a16:creationId xmlns:a16="http://schemas.microsoft.com/office/drawing/2014/main" id="{82F49AF6-9A5A-93C7-B5CB-2400820B899C}"/>
+              </a:ext>
+            </a:extLst>
+          </p:cNvPr>
+          <p:cNvSpPr/>
+          <p:nvPr/>
+        </p:nvSpPr>
+        <p:spPr>
+          <a:xfrm>
+            <a:off x="731520" y="4617720"/>
+            <a:ext cx="7680960" cy="365760"/>
+          </a:xfrm>
+          <a:prstGeom prst="rect">
+            <a:avLst/>
+          </a:prstGeom>
+          <a:noFill/>
+          <a:ln/>
+        </p:spPr>
+        <p:txBody>
+          <a:bodyPr wrap="square" rtlCol="0" anchor="ctr"/>
+          <a:lstStyle/>
+          <a:p>
+            <a:pPr marL="0" indent="0" algn="ctr">
+              <a:buNone/>
+            </a:pPr>
+            <a:r>
+              <a:rPr lang="en-US" sz="1100" dirty="0">
+                <a:solidFill>
+                  <a:srgbClr val="556688"/>
+                </a:solidFill>
+                <a:latin typeface="Calibri" pitchFamily="34" charset="0"/>
+                <a:ea typeface="Calibri" pitchFamily="34" charset="-122"/>
+                <a:cs typeface="Calibri" pitchFamily="34" charset="-120"/>
+              </a:rPr>
+              <a:t>Ben Heim &amp; Adam Tuchler  |  University of Chicago</a:t>
+            </a:r>
+            <a:endParaRPr lang="en-US" sz="1100" dirty="0"/>
+          </a:p>
+        </p:txBody>
+      </p:sp>
+    </p:spTree>
+    <p:extLst>
+      <p:ext uri="{BB962C8B-B14F-4D97-AF65-F5344CB8AC3E}">
+        <p14:creationId xmlns:p14="http://schemas.microsoft.com/office/powerpoint/2010/main" val="1971334516"/>
+      </p:ext>
+    </p:extLst>
+  </p:cSld>
+  <p:clrMapOvr>
+    <a:masterClrMapping/>
+  </p:clrMapOvr>
+</p:sld>
+</file>
+
+<file path=ppt/slides/slide21.xml><?xml version="1.0" encoding="utf-8"?>
+<p:sld xmlns:a="http://schemas.openxmlformats.org/drawingml/2006/main" xmlns:r="http://schemas.openxmlformats.org/officeDocument/2006/relationships" xmlns:p="http://schemas.openxmlformats.org/presentationml/2006/main">
+  <p:cSld>
+    <p:spTree>
+      <p:nvGrpSpPr>
+        <p:cNvPr id="1" name=""/>
+        <p:cNvGrpSpPr/>
+        <p:nvPr/>
+      </p:nvGrpSpPr>
+      <p:grpSpPr>
+        <a:xfrm>
+          <a:off x="0" y="0"/>
+          <a:ext cx="0" cy="0"/>
+          <a:chOff x="0" y="0"/>
+          <a:chExt cx="0" cy="0"/>
+        </a:xfrm>
+      </p:grpSpPr>
+      <p:sp>
+        <p:nvSpPr>
+          <p:cNvPr id="2" name="TextBox 1"/>
+          <p:cNvSpPr txBox="1"/>
+          <p:nvPr/>
+        </p:nvSpPr>
+        <p:spPr>
+          <a:xfrm>
+            <a:off x="548640" y="274320"/>
+            <a:ext cx="8046720" cy="548640"/>
+          </a:xfrm>
+          <a:prstGeom prst="rect">
+            <a:avLst/>
+          </a:prstGeom>
+          <a:noFill/>
+        </p:spPr>
+        <p:txBody>
+          <a:bodyPr wrap="square" anchor="t">
+            <a:spAutoFit/>
+          </a:bodyPr>
+          <a:lstStyle/>
+          <a:p>
+            <a:pPr algn="l">
+              <a:defRPr sz="2800" b="1" i="0">
+                <a:solidFill>
+                  <a:srgbClr val="1E2761"/>
+                </a:solidFill>
+                <a:latin typeface="Georgia"/>
+              </a:defRPr>
+            </a:pPr>
+            <a:r>
+              <a:t>Future Work</a:t>
+            </a:r>
+          </a:p>
+        </p:txBody>
+      </p:sp>
+      <p:sp>
+        <p:nvSpPr>
+          <p:cNvPr id="3" name="Oval 2"/>
+          <p:cNvSpPr/>
+          <p:nvPr/>
+        </p:nvSpPr>
+        <p:spPr>
+          <a:xfrm>
+            <a:off x="548640" y="1097280"/>
+            <a:ext cx="411480" cy="411480"/>
+          </a:xfrm>
+          <a:prstGeom prst="ellipse">
+            <a:avLst/>
+          </a:prstGeom>
+          <a:solidFill>
+            <a:srgbClr val="3A7BD5"/>
+          </a:solidFill>
+          <a:ln>
+            <a:noFill/>
+          </a:ln>
+        </p:spPr>
+        <p:style>
+          <a:lnRef idx="1">
+            <a:schemeClr val="accent1"/>
+          </a:lnRef>
+          <a:fillRef idx="3">
+            <a:schemeClr val="accent1"/>
+          </a:fillRef>
+          <a:effectRef idx="2">
+            <a:schemeClr val="accent1"/>
+          </a:effectRef>
+          <a:fontRef idx="minor">
+            <a:schemeClr val="lt1"/>
+          </a:fontRef>
+        </p:style>
+        <p:txBody>
+          <a:bodyPr wrap="none" rtlCol="0" anchor="ctr"/>
+          <a:lstStyle/>
+          <a:p>
+            <a:pPr algn="ctr">
+              <a:defRPr sz="1600" b="1">
+                <a:solidFill>
+                  <a:srgbClr val="FFFFFF"/>
+                </a:solidFill>
+                <a:latin typeface="Calibri"/>
+              </a:defRPr>
+            </a:pPr>
+            <a:r>
+              <a:t>1</a:t>
+            </a:r>
+          </a:p>
+        </p:txBody>
+      </p:sp>
+      <p:sp>
+        <p:nvSpPr>
+          <p:cNvPr id="4" name="TextBox 3"/>
+          <p:cNvSpPr txBox="1"/>
+          <p:nvPr/>
+        </p:nvSpPr>
+        <p:spPr>
+          <a:xfrm>
+            <a:off x="1188720" y="1097280"/>
+            <a:ext cx="7406640" cy="320040"/>
+          </a:xfrm>
+          <a:prstGeom prst="rect">
+            <a:avLst/>
+          </a:prstGeom>
+          <a:noFill/>
+        </p:spPr>
+        <p:txBody>
+          <a:bodyPr wrap="square" anchor="t">
+            <a:spAutoFit/>
+          </a:bodyPr>
+          <a:lstStyle/>
+          <a:p>
+            <a:pPr algn="l">
+              <a:defRPr sz="1600" b="1" i="0">
+                <a:solidFill>
+                  <a:srgbClr val="1E2761"/>
+                </a:solidFill>
+                <a:latin typeface="Calibri"/>
+              </a:defRPr>
+            </a:pPr>
+            <a:r>
+              <a:t>Do cross-disciplinary citations produce lasting impact?</a:t>
+            </a:r>
+          </a:p>
+        </p:txBody>
+      </p:sp>
+      <p:sp>
+        <p:nvSpPr>
+          <p:cNvPr id="5" name="TextBox 4"/>
+          <p:cNvSpPr txBox="1"/>
+          <p:nvPr/>
+        </p:nvSpPr>
+        <p:spPr>
+          <a:xfrm>
+            <a:off x="1188720" y="1444752"/>
+            <a:ext cx="7406640" cy="731520"/>
+          </a:xfrm>
+          <a:prstGeom prst="rect">
+            <a:avLst/>
+          </a:prstGeom>
+          <a:noFill/>
+        </p:spPr>
+        <p:txBody>
+          <a:bodyPr wrap="square" anchor="t">
+            <a:spAutoFit/>
+          </a:bodyPr>
+          <a:lstStyle/>
+          <a:p>
+            <a:pPr algn="l">
+              <a:defRPr sz="1200" b="0" i="0">
+                <a:solidFill>
+                  <a:srgbClr val="1E2761"/>
+                </a:solidFill>
+                <a:latin typeface="Calibri"/>
+              </a:defRPr>
+            </a:pPr>
+            <a:r>
+              <a:t>Track forward citations, disruption indices (CD₅), and knowledge persistence of AI-era papers over 3–5 years. Tests whether the entropy increase we document translates into genuine knowledge integration or superficial breadth — directly engaging Hao et al.’s knowledge contraction and Kusumegi et al.’s quality decline findings.</a:t>
+            </a:r>
+          </a:p>
+        </p:txBody>
+      </p:sp>
+      <p:sp>
+        <p:nvSpPr>
+          <p:cNvPr id="9" name="Oval 8"/>
+          <p:cNvSpPr/>
+          <p:nvPr/>
+        </p:nvSpPr>
+        <p:spPr>
+          <a:xfrm>
+            <a:off x="548640" y="2673192"/>
+            <a:ext cx="411480" cy="411480"/>
+          </a:xfrm>
+          <a:prstGeom prst="ellipse">
+            <a:avLst/>
+          </a:prstGeom>
+          <a:solidFill>
+            <a:srgbClr val="3A7BD5"/>
+          </a:solidFill>
+          <a:ln>
+            <a:noFill/>
+          </a:ln>
+        </p:spPr>
+        <p:style>
+          <a:lnRef idx="1">
+            <a:schemeClr val="accent1"/>
+          </a:lnRef>
+          <a:fillRef idx="3">
+            <a:schemeClr val="accent1"/>
+          </a:fillRef>
+          <a:effectRef idx="2">
+            <a:schemeClr val="accent1"/>
+          </a:effectRef>
+          <a:fontRef idx="minor">
+            <a:schemeClr val="lt1"/>
+          </a:fontRef>
+        </p:style>
+        <p:txBody>
+          <a:bodyPr wrap="none" rtlCol="0" anchor="ctr"/>
+          <a:lstStyle/>
+          <a:p>
+            <a:pPr algn="ctr">
+              <a:defRPr sz="1600" b="1">
+                <a:solidFill>
+                  <a:srgbClr val="FFFFFF"/>
+                </a:solidFill>
+                <a:latin typeface="Calibri"/>
+              </a:defRPr>
+            </a:pPr>
+            <a:r>
+              <a:rPr lang="en-US" dirty="0"/>
+              <a:t>2</a:t>
+            </a:r>
+            <a:endParaRPr dirty="0"/>
+          </a:p>
+        </p:txBody>
+      </p:sp>
+      <p:sp>
+        <p:nvSpPr>
+          <p:cNvPr id="10" name="TextBox 9"/>
+          <p:cNvSpPr txBox="1"/>
+          <p:nvPr/>
+        </p:nvSpPr>
+        <p:spPr>
+          <a:xfrm>
+            <a:off x="1188720" y="2647189"/>
+            <a:ext cx="7406640" cy="320040"/>
+          </a:xfrm>
+          <a:prstGeom prst="rect">
+            <a:avLst/>
+          </a:prstGeom>
+          <a:noFill/>
+        </p:spPr>
+        <p:txBody>
+          <a:bodyPr wrap="square" anchor="t">
+            <a:spAutoFit/>
+          </a:bodyPr>
+          <a:lstStyle/>
+          <a:p>
+            <a:pPr algn="l">
+              <a:defRPr sz="1600" b="1" i="0">
+                <a:solidFill>
+                  <a:srgbClr val="1E2761"/>
+                </a:solidFill>
+                <a:latin typeface="Calibri"/>
+              </a:defRPr>
+            </a:pPr>
+            <a:r>
+              <a:t>Disentangle the mechanism</a:t>
+            </a:r>
+          </a:p>
+        </p:txBody>
+      </p:sp>
+      <p:sp>
+        <p:nvSpPr>
+          <p:cNvPr id="11" name="TextBox 10"/>
+          <p:cNvSpPr txBox="1"/>
+          <p:nvPr/>
+        </p:nvSpPr>
+        <p:spPr>
+          <a:xfrm>
+            <a:off x="1188720" y="2994661"/>
+            <a:ext cx="7406640" cy="594360"/>
+          </a:xfrm>
+          <a:prstGeom prst="rect">
+            <a:avLst/>
+          </a:prstGeom>
+          <a:noFill/>
+        </p:spPr>
+        <p:txBody>
+          <a:bodyPr wrap="square" anchor="t">
+            <a:spAutoFit/>
+          </a:bodyPr>
+          <a:lstStyle/>
+          <a:p>
+            <a:pPr algn="l">
+              <a:defRPr sz="1200" b="0" i="0">
+                <a:solidFill>
+                  <a:srgbClr val="1E2761"/>
+                </a:solidFill>
+                <a:latin typeface="Calibri"/>
+              </a:defRPr>
+            </a:pPr>
+            <a:r>
+              <a:rPr dirty="0"/>
+              <a:t>Are researchers discovering new literatures through LLM suggestions (</a:t>
+            </a:r>
+            <a:r>
+              <a:rPr dirty="0" err="1"/>
+              <a:t>Algaba’s</a:t>
+            </a:r>
+            <a:r>
+              <a:rPr dirty="0"/>
+              <a:t> channel), or does LLM-assisted writing lower the cost of integrating sources they already knew about? Experimental or survey-based designs could separate these pathways.</a:t>
+            </a:r>
+          </a:p>
+        </p:txBody>
+      </p:sp>
+    </p:spTree>
+  </p:cSld>
+  <p:clrMapOvr>
+    <a:masterClrMapping/>
+  </p:clrMapOvr>
+</p:sld>
+</file>
+
+<file path=ppt/slides/slide22.xml><?xml version="1.0" encoding="utf-8"?>
+<p:sld xmlns:a="http://schemas.openxmlformats.org/drawingml/2006/main" xmlns:r="http://schemas.openxmlformats.org/officeDocument/2006/relationships" xmlns:p="http://schemas.openxmlformats.org/presentationml/2006/main">
+  <p:cSld>
+    <p:spTree>
+      <p:nvGrpSpPr>
+        <p:cNvPr id="1" name="">
+          <a:extLst>
+            <a:ext uri="{FF2B5EF4-FFF2-40B4-BE49-F238E27FC236}">
+              <a16:creationId xmlns:a16="http://schemas.microsoft.com/office/drawing/2014/main" id="{B345F5B4-A69B-E2E7-0403-AE63E1553D8D}"/>
+            </a:ext>
+          </a:extLst>
+        </p:cNvPr>
+        <p:cNvGrpSpPr/>
+        <p:nvPr/>
+      </p:nvGrpSpPr>
+      <p:grpSpPr>
+        <a:xfrm>
+          <a:off x="0" y="0"/>
+          <a:ext cx="0" cy="0"/>
+          <a:chOff x="0" y="0"/>
+          <a:chExt cx="0" cy="0"/>
+        </a:xfrm>
+      </p:grpSpPr>
+      <p:sp>
+        <p:nvSpPr>
+          <p:cNvPr id="2" name="TextBox 1">
+            <a:extLst>
+              <a:ext uri="{FF2B5EF4-FFF2-40B4-BE49-F238E27FC236}">
+                <a16:creationId xmlns:a16="http://schemas.microsoft.com/office/drawing/2014/main" id="{E776359B-E6CD-8761-7948-B6E13C002401}"/>
+              </a:ext>
+            </a:extLst>
+          </p:cNvPr>
+          <p:cNvSpPr txBox="1"/>
+          <p:nvPr/>
+        </p:nvSpPr>
+        <p:spPr>
+          <a:xfrm>
+            <a:off x="548640" y="274320"/>
+            <a:ext cx="8046720" cy="548640"/>
+          </a:xfrm>
+          <a:prstGeom prst="rect">
+            <a:avLst/>
+          </a:prstGeom>
+          <a:noFill/>
+        </p:spPr>
+        <p:txBody>
+          <a:bodyPr wrap="square" anchor="t">
+            <a:spAutoFit/>
+          </a:bodyPr>
+          <a:lstStyle/>
+          <a:p>
+            <a:pPr algn="l">
+              <a:defRPr sz="2800" b="1" i="0">
+                <a:solidFill>
+                  <a:srgbClr val="1E2761"/>
+                </a:solidFill>
+                <a:latin typeface="Georgia"/>
+              </a:defRPr>
+            </a:pPr>
+            <a:r>
+              <a:t>Future Work</a:t>
+            </a:r>
+          </a:p>
+        </p:txBody>
+      </p:sp>
+      <p:sp>
+        <p:nvSpPr>
+          <p:cNvPr id="3" name="Oval 2">
+            <a:extLst>
+              <a:ext uri="{FF2B5EF4-FFF2-40B4-BE49-F238E27FC236}">
+                <a16:creationId xmlns:a16="http://schemas.microsoft.com/office/drawing/2014/main" id="{041C5287-0FE3-8E97-1B0A-FE682638A16E}"/>
+              </a:ext>
+            </a:extLst>
+          </p:cNvPr>
+          <p:cNvSpPr/>
+          <p:nvPr/>
+        </p:nvSpPr>
+        <p:spPr>
+          <a:xfrm>
+            <a:off x="548640" y="1097280"/>
+            <a:ext cx="411480" cy="411480"/>
+          </a:xfrm>
+          <a:prstGeom prst="ellipse">
+            <a:avLst/>
+          </a:prstGeom>
+          <a:solidFill>
+            <a:srgbClr val="3A7BD5"/>
+          </a:solidFill>
+          <a:ln>
+            <a:noFill/>
+          </a:ln>
+        </p:spPr>
+        <p:style>
+          <a:lnRef idx="1">
+            <a:schemeClr val="accent1"/>
+          </a:lnRef>
+          <a:fillRef idx="3">
+            <a:schemeClr val="accent1"/>
+          </a:fillRef>
+          <a:effectRef idx="2">
+            <a:schemeClr val="accent1"/>
+          </a:effectRef>
+          <a:fontRef idx="minor">
+            <a:schemeClr val="lt1"/>
+          </a:fontRef>
+        </p:style>
+        <p:txBody>
+          <a:bodyPr wrap="none" rtlCol="0" anchor="ctr"/>
+          <a:lstStyle/>
+          <a:p>
+            <a:pPr algn="ctr">
+              <a:defRPr sz="1600" b="1">
+                <a:solidFill>
+                  <a:srgbClr val="FFFFFF"/>
+                </a:solidFill>
+                <a:latin typeface="Calibri"/>
+              </a:defRPr>
+            </a:pPr>
+            <a:r>
+              <a:t>1</a:t>
+            </a:r>
+          </a:p>
+        </p:txBody>
+      </p:sp>
+      <p:sp>
+        <p:nvSpPr>
+          <p:cNvPr id="4" name="TextBox 3">
+            <a:extLst>
+              <a:ext uri="{FF2B5EF4-FFF2-40B4-BE49-F238E27FC236}">
+                <a16:creationId xmlns:a16="http://schemas.microsoft.com/office/drawing/2014/main" id="{3F17FBED-E4D2-796B-BD22-00F754A161E0}"/>
+              </a:ext>
+            </a:extLst>
+          </p:cNvPr>
+          <p:cNvSpPr txBox="1"/>
+          <p:nvPr/>
+        </p:nvSpPr>
+        <p:spPr>
+          <a:xfrm>
+            <a:off x="1188720" y="1097280"/>
+            <a:ext cx="7406640" cy="320040"/>
+          </a:xfrm>
+          <a:prstGeom prst="rect">
+            <a:avLst/>
+          </a:prstGeom>
+          <a:noFill/>
+        </p:spPr>
+        <p:txBody>
+          <a:bodyPr wrap="square" anchor="t">
+            <a:spAutoFit/>
+          </a:bodyPr>
+          <a:lstStyle/>
+          <a:p>
+            <a:pPr algn="l">
+              <a:defRPr sz="1600" b="1" i="0">
+                <a:solidFill>
+                  <a:srgbClr val="1E2761"/>
+                </a:solidFill>
+                <a:latin typeface="Calibri"/>
+              </a:defRPr>
+            </a:pPr>
+            <a:r>
+              <a:t>Do cross-disciplinary citations produce lasting impact?</a:t>
+            </a:r>
+          </a:p>
+        </p:txBody>
+      </p:sp>
+      <p:sp>
+        <p:nvSpPr>
+          <p:cNvPr id="5" name="TextBox 4">
+            <a:extLst>
+              <a:ext uri="{FF2B5EF4-FFF2-40B4-BE49-F238E27FC236}">
+                <a16:creationId xmlns:a16="http://schemas.microsoft.com/office/drawing/2014/main" id="{02F217BF-D9B1-CC70-C384-836A3AAF3A1F}"/>
+              </a:ext>
+            </a:extLst>
+          </p:cNvPr>
+          <p:cNvSpPr txBox="1"/>
+          <p:nvPr/>
+        </p:nvSpPr>
+        <p:spPr>
+          <a:xfrm>
+            <a:off x="1188720" y="1444752"/>
+            <a:ext cx="7406640" cy="731520"/>
+          </a:xfrm>
+          <a:prstGeom prst="rect">
+            <a:avLst/>
+          </a:prstGeom>
+          <a:noFill/>
+        </p:spPr>
+        <p:txBody>
+          <a:bodyPr wrap="square" anchor="t">
+            <a:spAutoFit/>
+          </a:bodyPr>
+          <a:lstStyle/>
+          <a:p>
+            <a:pPr algn="l">
+              <a:defRPr sz="1200" b="0" i="0">
+                <a:solidFill>
+                  <a:srgbClr val="1E2761"/>
+                </a:solidFill>
+                <a:latin typeface="Calibri"/>
+              </a:defRPr>
+            </a:pPr>
+            <a:r>
+              <a:t>Track forward citations, disruption indices (CD₅), and knowledge persistence of AI-era papers over 3–5 years. Tests whether the entropy increase we document translates into genuine knowledge integration or superficial breadth — directly engaging Hao et al.’s knowledge contraction and Kusumegi et al.’s quality decline findings.</a:t>
+            </a:r>
+          </a:p>
+        </p:txBody>
+      </p:sp>
+      <p:sp>
+        <p:nvSpPr>
+          <p:cNvPr id="9" name="Oval 8">
+            <a:extLst>
+              <a:ext uri="{FF2B5EF4-FFF2-40B4-BE49-F238E27FC236}">
+                <a16:creationId xmlns:a16="http://schemas.microsoft.com/office/drawing/2014/main" id="{21C25903-4BAE-36D9-CFAA-5EAABE335B88}"/>
+              </a:ext>
+            </a:extLst>
+          </p:cNvPr>
+          <p:cNvSpPr/>
+          <p:nvPr/>
+        </p:nvSpPr>
+        <p:spPr>
+          <a:xfrm>
+            <a:off x="548640" y="2673192"/>
+            <a:ext cx="411480" cy="411480"/>
+          </a:xfrm>
+          <a:prstGeom prst="ellipse">
+            <a:avLst/>
+          </a:prstGeom>
+          <a:solidFill>
+            <a:srgbClr val="3A7BD5"/>
+          </a:solidFill>
+          <a:ln>
+            <a:noFill/>
+          </a:ln>
+        </p:spPr>
+        <p:style>
+          <a:lnRef idx="1">
+            <a:schemeClr val="accent1"/>
+          </a:lnRef>
+          <a:fillRef idx="3">
+            <a:schemeClr val="accent1"/>
+          </a:fillRef>
+          <a:effectRef idx="2">
+            <a:schemeClr val="accent1"/>
+          </a:effectRef>
+          <a:fontRef idx="minor">
+            <a:schemeClr val="lt1"/>
+          </a:fontRef>
+        </p:style>
+        <p:txBody>
+          <a:bodyPr wrap="none" rtlCol="0" anchor="ctr"/>
+          <a:lstStyle/>
+          <a:p>
+            <a:pPr algn="ctr">
+              <a:defRPr sz="1600" b="1">
+                <a:solidFill>
+                  <a:srgbClr val="FFFFFF"/>
+                </a:solidFill>
+                <a:latin typeface="Calibri"/>
+              </a:defRPr>
+            </a:pPr>
+            <a:r>
+              <a:rPr lang="en-US" dirty="0"/>
+              <a:t>2</a:t>
+            </a:r>
+            <a:endParaRPr dirty="0"/>
+          </a:p>
+        </p:txBody>
+      </p:sp>
+      <p:sp>
+        <p:nvSpPr>
+          <p:cNvPr id="10" name="TextBox 9">
+            <a:extLst>
+              <a:ext uri="{FF2B5EF4-FFF2-40B4-BE49-F238E27FC236}">
+                <a16:creationId xmlns:a16="http://schemas.microsoft.com/office/drawing/2014/main" id="{0B7AB8CF-36BE-CA0E-E220-5C883DC161E5}"/>
+              </a:ext>
+            </a:extLst>
+          </p:cNvPr>
+          <p:cNvSpPr txBox="1"/>
+          <p:nvPr/>
+        </p:nvSpPr>
+        <p:spPr>
+          <a:xfrm>
+            <a:off x="1188720" y="2647189"/>
+            <a:ext cx="7406640" cy="320040"/>
+          </a:xfrm>
+          <a:prstGeom prst="rect">
+            <a:avLst/>
+          </a:prstGeom>
+          <a:noFill/>
+        </p:spPr>
+        <p:txBody>
+          <a:bodyPr wrap="square" anchor="t">
+            <a:spAutoFit/>
+          </a:bodyPr>
+          <a:lstStyle/>
+          <a:p>
+            <a:pPr algn="l">
+              <a:defRPr sz="1600" b="1" i="0">
+                <a:solidFill>
+                  <a:srgbClr val="1E2761"/>
+                </a:solidFill>
+                <a:latin typeface="Calibri"/>
+              </a:defRPr>
+            </a:pPr>
+            <a:r>
+              <a:t>Disentangle the mechanism</a:t>
+            </a:r>
+          </a:p>
+        </p:txBody>
+      </p:sp>
+      <p:sp>
+        <p:nvSpPr>
+          <p:cNvPr id="11" name="TextBox 10">
+            <a:extLst>
+              <a:ext uri="{FF2B5EF4-FFF2-40B4-BE49-F238E27FC236}">
+                <a16:creationId xmlns:a16="http://schemas.microsoft.com/office/drawing/2014/main" id="{1B18FB47-9546-0311-95A4-AD858A37B48D}"/>
+              </a:ext>
+            </a:extLst>
+          </p:cNvPr>
+          <p:cNvSpPr txBox="1"/>
+          <p:nvPr/>
+        </p:nvSpPr>
+        <p:spPr>
+          <a:xfrm>
+            <a:off x="1188720" y="2994661"/>
+            <a:ext cx="7406640" cy="594360"/>
+          </a:xfrm>
+          <a:prstGeom prst="rect">
+            <a:avLst/>
+          </a:prstGeom>
+          <a:noFill/>
+        </p:spPr>
+        <p:txBody>
+          <a:bodyPr wrap="square" anchor="t">
+            <a:spAutoFit/>
+          </a:bodyPr>
+          <a:lstStyle/>
+          <a:p>
+            <a:pPr algn="l">
+              <a:defRPr sz="1200" b="0" i="0">
+                <a:solidFill>
+                  <a:srgbClr val="1E2761"/>
+                </a:solidFill>
+                <a:latin typeface="Calibri"/>
+              </a:defRPr>
+            </a:pPr>
+            <a:r>
+              <a:rPr dirty="0"/>
+              <a:t>Are researchers discovering new literatures through LLM suggestions (</a:t>
+            </a:r>
+            <a:r>
+              <a:rPr dirty="0" err="1"/>
+              <a:t>Algaba’s</a:t>
+            </a:r>
+            <a:r>
+              <a:rPr dirty="0"/>
+              <a:t> channel), or does LLM-assisted writing lower the cost of integrating sources they already knew about? Experimental or survey-based designs could separate these pathways.</a:t>
+            </a:r>
+          </a:p>
+        </p:txBody>
+      </p:sp>
+    </p:spTree>
+    <p:extLst>
+      <p:ext uri="{BB962C8B-B14F-4D97-AF65-F5344CB8AC3E}">
+        <p14:creationId xmlns:p14="http://schemas.microsoft.com/office/powerpoint/2010/main" val="2340358712"/>
+      </p:ext>
+    </p:extLst>
   </p:cSld>
   <p:clrMapOvr>
     <a:masterClrMapping/>
@@ -10886,7 +12657,7 @@
         <p:spPr>
           <a:xfrm>
             <a:off x="5251269" y="1172817"/>
-            <a:ext cx="3516521" cy="2893100"/>
+            <a:ext cx="3516521" cy="1815882"/>
           </a:xfrm>
           <a:prstGeom prst="rect">
             <a:avLst/>
@@ -10917,19 +12688,6 @@
               <a:rPr lang="en-US" sz="1400" dirty="0"/>
               <a:t>We measure AI propensity by using (marker words per million 6 months after GPT 3.5 release – marker words per million before GPT 3.5 release)/(marker words per million before GPT 3.5 release)</a:t>
             </a:r>
-          </a:p>
-          <a:p>
-            <a:pPr marL="285750" indent="-285750">
-              <a:buFont typeface="Arial" panose="020B0604020202020204" pitchFamily="34" charset="0"/>
-              <a:buChar char="•"/>
-            </a:pPr>
-            <a:r>
-              <a:rPr lang="en-US" sz="1400" dirty="0"/>
-              <a:t>Fields more amenable to LLM use like CS and Business see higher AI propensities whereas fields less amenable (math, medicine) see lower scores</a:t>
-            </a:r>
-          </a:p>
-          <a:p>
-            <a:endParaRPr lang="en-US" sz="1400" dirty="0"/>
           </a:p>
         </p:txBody>
       </p:sp>

</xml_diff>